<commit_message>
DOC: Identification formelle de l etudiant Feugang Noussi, Bernard (Matricule 6189470) sur tous les livrables
</commit_message>
<xml_diff>
--- a/presentation_rxneurones_lenet5.pptx
+++ b/presentation_rxneurones_lenet5.pptx
@@ -509,7 +509,7 @@
           <a:lstStyle/>
           <a:p>
             <a:r>
-              <a:t>Bonjour à tous. Je vous présente aujourd'hui LeNet-5, conçue en 1998 par Yann LeCun et son équipe. C'est une architecture strictement CONVOLUTIVE (CNN), pionnière du deep learning.</a:t>
+              <a:t>Bonjour à tous. Je m'appelle Bernard Feugang Noussi (matricule 6189470). Je vous présente aujourd'hui l'architecture LeNet-5, conçue en 1998 par Yann LeCun. C'est une architecture strictement CONVOLUTIVE (CNN).</a:t>
             </a:r>
           </a:p>
         </p:txBody>
@@ -4013,8 +4013,8 @@
         </p:nvSpPr>
         <p:spPr>
           <a:xfrm>
-            <a:off x="914400" y="822960"/>
-            <a:ext cx="10362895" cy="5212080"/>
+            <a:off x="914400" y="777240"/>
+            <a:ext cx="10362895" cy="5303520"/>
           </a:xfrm>
           <a:prstGeom prst="roundRect">
             <a:avLst/>
@@ -4058,8 +4058,8 @@
         </p:nvSpPr>
         <p:spPr>
           <a:xfrm>
-            <a:off x="1371600" y="1234440"/>
-            <a:ext cx="4389120" cy="384048"/>
+            <a:off x="1371600" y="1143000"/>
+            <a:ext cx="4754880" cy="384048"/>
           </a:xfrm>
           <a:prstGeom prst="roundRect">
             <a:avLst/>
@@ -4092,14 +4092,14 @@
           <a:lstStyle/>
           <a:p>
             <a:pPr algn="ctr">
-              <a:defRPr sz="1000" b="1">
+              <a:defRPr sz="1050" b="1">
                 <a:solidFill>
                   <a:srgbClr val="0969DA"/>
                 </a:solidFill>
               </a:defRPr>
             </a:pPr>
             <a:r>
-              <a:t>ARCHITECTURE ASSIGNÉE : RÉSEAU CONVOLUTIF (CNN)</a:t>
+              <a:t>ARCHITECTURE N°6 : RÉSEAU CONVOLUTIF (CNN)</a:t>
             </a:r>
           </a:p>
         </p:txBody>
@@ -4112,7 +4112,7 @@
         </p:nvSpPr>
         <p:spPr>
           <a:xfrm>
-            <a:off x="1371600" y="1737360"/>
+            <a:off x="1371600" y="1645920"/>
             <a:ext cx="9418320" cy="2011680"/>
           </a:xfrm>
           <a:prstGeom prst="rect">
@@ -4127,7 +4127,7 @@
           <a:lstStyle/>
           <a:p>
             <a:pPr>
-              <a:defRPr sz="3000" b="1">
+              <a:defRPr sz="2900" b="1">
                 <a:solidFill>
                   <a:srgbClr val="0F172A"/>
                 </a:solidFill>
@@ -4144,9 +4144,9 @@
           <a:p>
             <a:pPr>
               <a:spcBef>
-                <a:spcPts val="1000"/>
+                <a:spcPts val="800"/>
               </a:spcBef>
-              <a:defRPr sz="1500">
+              <a:defRPr sz="1400">
                 <a:solidFill>
                   <a:srgbClr val="475569"/>
                 </a:solidFill>
@@ -4166,8 +4166,8 @@
         </p:nvSpPr>
         <p:spPr>
           <a:xfrm>
-            <a:off x="1371600" y="4114800"/>
-            <a:ext cx="9418320" cy="1463040"/>
+            <a:off x="1371600" y="3931920"/>
+            <a:ext cx="9418320" cy="1828800"/>
           </a:xfrm>
           <a:prstGeom prst="roundRect">
             <a:avLst/>
@@ -4175,9 +4175,9 @@
           <a:solidFill>
             <a:srgbClr val="F8FAFC"/>
           </a:solidFill>
-          <a:ln>
+          <a:ln w="19050">
             <a:solidFill>
-              <a:srgbClr val="E2E8F0"/>
+              <a:srgbClr val="0969DA"/>
             </a:solidFill>
           </a:ln>
         </p:spPr>
@@ -4200,14 +4200,29 @@
           <a:lstStyle/>
           <a:p>
             <a:pPr algn="ctr">
-              <a:defRPr sz="1300" b="1">
+              <a:defRPr sz="1400" b="1">
+                <a:solidFill>
+                  <a:srgbClr val="0969DA"/>
+                </a:solidFill>
+              </a:defRPr>
+            </a:pPr>
+            <a:r>
+              <a:t>👨‍🎓 Étudiant : Feugang Noussi, Bernard        |        Matricule / N° Étudiant : 6189470</a:t>
+            </a:r>
+          </a:p>
+          <a:p>
+            <a:pPr>
+              <a:spcBef>
+                <a:spcPts val="400"/>
+              </a:spcBef>
+              <a:defRPr sz="1200" b="1">
                 <a:solidFill>
                   <a:srgbClr val="0F172A"/>
                 </a:solidFill>
               </a:defRPr>
             </a:pPr>
             <a:r>
-              <a:t>👨‍🎓 Étudiant : Bernard Feugang Noussi     |     📚 Cours : 420-A60-BB (Apprentissage Profond - Été 2026)</a:t>
+              <a:t>📚 Cours : 420-A60-BB — Algorithmes d'Apprentissage Profond (Session Été 2026)</a:t>
             </a:r>
           </a:p>
           <a:p>
@@ -4217,7 +4232,7 @@
               </a:spcBef>
               <a:defRPr sz="1100">
                 <a:solidFill>
-                  <a:srgbClr val="0969DA"/>
+                  <a:srgbClr val="475569"/>
                 </a:solidFill>
               </a:defRPr>
             </a:pPr>
@@ -4232,12 +4247,12 @@
               </a:spcBef>
               <a:defRPr sz="1100">
                 <a:solidFill>
-                  <a:srgbClr val="475569"/>
-                </a:solidFill>
-              </a:defRPr>
-            </a:pPr>
-            <a:r>
-              <a:t>⏱️ Format de présentation : 7 minutes (+ 3 minutes de questions)  |  Livrable HTML interactif inclus</a:t>
+                  <a:srgbClr val="16A34A"/>
+                </a:solidFill>
+              </a:defRPr>
+            </a:pPr>
+            <a:r>
+              <a:t>⏱️ Format officiel : 7 minutes (+ 3 minutes de questions)  |  Dossier Web interactif inclus</a:t>
             </a:r>
           </a:p>
         </p:txBody>
@@ -4398,14 +4413,14 @@
           <a:lstStyle/>
           <a:p>
             <a:pPr>
-              <a:defRPr sz="900">
+              <a:defRPr sz="950">
                 <a:solidFill>
                   <a:srgbClr val="475569"/>
                 </a:solidFill>
               </a:defRPr>
             </a:pPr>
             <a:r>
-              <a:t>LeNet-5 (1998) | Bernard Feugang Noussi | Slide 2/8  (0:45 - 1:45) | Réf: LeCun et al. (1998)</a:t>
+              <a:t>LeNet-5 (1998) | Feugang Noussi, Bernard (Matricule: 6189470) | Slide 2/8  (0:45 - 1:45) | Réf: LeCun et al. (1998)</a:t>
             </a:r>
           </a:p>
         </p:txBody>
@@ -4685,14 +4700,14 @@
           <a:lstStyle/>
           <a:p>
             <a:pPr>
-              <a:defRPr sz="900">
+              <a:defRPr sz="950">
                 <a:solidFill>
                   <a:srgbClr val="475569"/>
                 </a:solidFill>
               </a:defRPr>
             </a:pPr>
             <a:r>
-              <a:t>LeNet-5 (1998) | Bernard Feugang Noussi | Slide 3/8  (1:45 - 3:00) | Réf: LeCun et al. (1998)</a:t>
+              <a:t>LeNet-5 (1998) | Feugang Noussi, Bernard (Matricule: 6189470) | Slide 3/8  (1:45 - 3:00) | Réf: LeCun et al. (1998)</a:t>
             </a:r>
           </a:p>
         </p:txBody>
@@ -5433,14 +5448,14 @@
           <a:lstStyle/>
           <a:p>
             <a:pPr>
-              <a:defRPr sz="900">
+              <a:defRPr sz="950">
                 <a:solidFill>
                   <a:srgbClr val="475569"/>
                 </a:solidFill>
               </a:defRPr>
             </a:pPr>
             <a:r>
-              <a:t>LeNet-5 (1998) | Bernard Feugang Noussi | Slide 4/8  (3:00 - 4:00) | Réf: LeCun et al. (1998)</a:t>
+              <a:t>LeNet-5 (1998) | Feugang Noussi, Bernard (Matricule: 6189470) | Slide 4/8  (3:00 - 4:00) | Réf: LeCun et al. (1998)</a:t>
             </a:r>
           </a:p>
         </p:txBody>
@@ -5720,14 +5735,14 @@
           <a:lstStyle/>
           <a:p>
             <a:pPr>
-              <a:defRPr sz="900">
+              <a:defRPr sz="950">
                 <a:solidFill>
                   <a:srgbClr val="475569"/>
                 </a:solidFill>
               </a:defRPr>
             </a:pPr>
             <a:r>
-              <a:t>LeNet-5 (1998) | Bernard Feugang Noussi | Slide 5/8  (4:00 - 4:50) | Réf: LeCun et al. (1998)</a:t>
+              <a:t>LeNet-5 (1998) | Feugang Noussi, Bernard (Matricule: 6189470) | Slide 5/8  (4:00 - 4:50) | Réf: LeCun et al. (1998)</a:t>
             </a:r>
           </a:p>
         </p:txBody>
@@ -6007,14 +6022,14 @@
           <a:lstStyle/>
           <a:p>
             <a:pPr>
-              <a:defRPr sz="900">
+              <a:defRPr sz="950">
                 <a:solidFill>
                   <a:srgbClr val="475569"/>
                 </a:solidFill>
               </a:defRPr>
             </a:pPr>
             <a:r>
-              <a:t>LeNet-5 (1998) | Bernard Feugang Noussi | Slide 6/8  (4:50 - 5:40) | Réf: LeCun et al. (1998)</a:t>
+              <a:t>LeNet-5 (1998) | Feugang Noussi, Bernard (Matricule: 6189470) | Slide 6/8  (4:50 - 5:40) | Réf: LeCun et al. (1998)</a:t>
             </a:r>
           </a:p>
         </p:txBody>
@@ -6403,14 +6418,14 @@
           <a:lstStyle/>
           <a:p>
             <a:pPr>
-              <a:defRPr sz="900">
+              <a:defRPr sz="950">
                 <a:solidFill>
                   <a:srgbClr val="475569"/>
                 </a:solidFill>
               </a:defRPr>
             </a:pPr>
             <a:r>
-              <a:t>LeNet-5 (1998) | Bernard Feugang Noussi | Slide 7/8  (5:40 - 6:25) | Réf: LeCun et al. (1998)</a:t>
+              <a:t>LeNet-5 (1998) | Feugang Noussi, Bernard (Matricule: 6189470) | Slide 7/8  (5:40 - 6:25) | Réf: LeCun et al. (1998)</a:t>
             </a:r>
           </a:p>
         </p:txBody>
@@ -6571,7 +6586,7 @@
               </a:defRPr>
             </a:pPr>
             <a:r>
-              <a:t>Comprend 3 animations interactives pas à pas (Convolution, Neurone, Descente d'erreur) et un quiz de 10 questions d'auto-évaluation.</a:t>
+              <a:t>Auteur : Feugang Noussi, Bernard (6189470) — Comprend 3 animations interactives et un quiz de 10 questions.</a:t>
             </a:r>
           </a:p>
         </p:txBody>
@@ -6732,14 +6747,14 @@
           <a:lstStyle/>
           <a:p>
             <a:pPr>
-              <a:defRPr sz="900">
+              <a:defRPr sz="950">
                 <a:solidFill>
                   <a:srgbClr val="475569"/>
                 </a:solidFill>
               </a:defRPr>
             </a:pPr>
             <a:r>
-              <a:t>LeNet-5 (1998) | Bernard Feugang Noussi | Slide 8/8  (6:25 - 7:00) | Réf: LeCun et al. (1998)</a:t>
+              <a:t>LeNet-5 (1998) | Feugang Noussi, Bernard (Matricule: 6189470) | Slide 8/8  (6:25 - 7:00) | Réf: LeCun et al. (1998)</a:t>
             </a:r>
           </a:p>
         </p:txBody>
@@ -6827,14 +6842,14 @@
               <a:spcBef>
                 <a:spcPts val="1600"/>
               </a:spcBef>
-              <a:defRPr sz="1800" b="1">
+              <a:defRPr sz="1700" b="1">
                 <a:solidFill>
                   <a:srgbClr val="0969DA"/>
                 </a:solidFill>
               </a:defRPr>
             </a:pPr>
             <a:r>
-              <a:t>💬 Merci pour votre attention. Place aux questions !</a:t>
+              <a:t>💬 Merci pour votre attention ! (Feugang Noussi Bernard — 6189470)</a:t>
             </a:r>
           </a:p>
         </p:txBody>

</xml_diff>

<commit_message>
FEAT: Integration des animations Remotion directement dans les diapositives PowerPoint (Convolution, Neurone, Pooling, Pipeline)
</commit_message>
<xml_diff>
--- a/presentation_rxneurones_lenet5.pptx
+++ b/presentation_rxneurones_lenet5.pptx
@@ -509,7 +509,7 @@
           <a:lstStyle/>
           <a:p>
             <a:r>
-              <a:t>Bonjour à tous. Je m'appelle Bernard Feugang Noussi (matricule 6189470). Je vous présente aujourd'hui l'architecture LeNet-5, conçue en 1998 par Yann LeCun. C'est une architecture strictement CONVOLUTIVE (CNN).</a:t>
+              <a:t>Bonjour à tous. Je m'appelle Bernard Feugang Noussi (matricule 6189470). Je vous présente l'architecture LeNet-5 (1998), pionnière des réseaux convolutifs (CNN).</a:t>
             </a:r>
           </a:p>
         </p:txBody>
@@ -579,7 +579,7 @@
           <a:lstStyle/>
           <a:p>
             <a:r>
-              <a:t>Avant LeNet-5, les réseaux fully-connected détruisaient la 2D et explosaient en nombre de poids. LeNet-5 résout ce problème fondamental par la convolution locale.</a:t>
+              <a:t>Regardez l'animation à droite : le filtre 3x3 glisse pixel par pixel sur le chiffre 7 pour remplir en direct la carte de caractéristiques.</a:t>
             </a:r>
           </a:p>
         </p:txBody>
@@ -649,7 +649,7 @@
           <a:lstStyle/>
           <a:p>
             <a:r>
-              <a:t>Voici le pipeline historique en 7 couches : 2 blocs Convolution-Subsampling (C1-S2 puis C3-S4) qui réduisent la taille tout en enrichissant les filtres, suivis de couches denses de classification (C5, F6, Sortie).</a:t>
+              <a:t>L'animation illustre la propagation du signal à travers les 7 couches de LeNet-5 : des deux blocs Convolution-Subsampling (C1-S2, C3-S4) jusqu'aux couches de classification denses.</a:t>
             </a:r>
           </a:p>
         </p:txBody>
@@ -719,7 +719,7 @@
           <a:lstStyle/>
           <a:p>
             <a:r>
-              <a:t>Dans l'article de 1998, LeCun rapporte un taux d'erreur de 0,8% sur MNIST avec 60 000 paramètres, surpassant tous les SVM et arbres de l'époque.</a:t>
+              <a:t>Le graphique animé à droite montre comment le neurone active sa sortie dès que la somme pondérée dépasse le seuil requis de 2.0.</a:t>
             </a:r>
           </a:p>
         </p:txBody>
@@ -859,7 +859,7 @@
           <a:lstStyle/>
           <a:p>
             <a:r>
-              <a:t>En résumé des forces et faiblesses : une robustesse et compacité exceptionnelles, mais limité aux petites images 32x32 et freiné par les sigmoïdes et la puissance de calcul de 1998.</a:t>
+              <a:t>Le Max-Pooling animé à droite montre comment la compression 2x2 retient la valeur 88 pour assurer l'invariance aux déformations.</a:t>
             </a:r>
           </a:p>
         </p:txBody>
@@ -929,7 +929,7 @@
           <a:lstStyle/>
           <a:p>
             <a:r>
-              <a:t>LeNet-5 est l'ancêtre direct d'AlexNet et de tous les modèles de vision modernes. Sans lui, la vision par ordinateur n'aurait pas connu cette explosion.</a:t>
+              <a:t>LeNet-5 est l'ancêtre direct d'AlexNet et de tous les modèles de vision modernes. Des outils de démonstration interactifs (Colab &amp; Web) accompagnent ce travail.</a:t>
             </a:r>
           </a:p>
         </p:txBody>
@@ -4153,7 +4153,7 @@
               </a:defRPr>
             </a:pPr>
             <a:r>
-              <a:t>Analyse complète, fonctionnement interne, déploiement industriel et impact historique.</a:t>
+              <a:t>Analyse complète, fonctionnement interne, animations Remotion et impact historique.</a:t>
             </a:r>
           </a:p>
         </p:txBody>
@@ -4252,7 +4252,7 @@
               </a:defRPr>
             </a:pPr>
             <a:r>
-              <a:t>⏱️ Format officiel : 7 minutes (+ 3 minutes de questions)  |  Dossier Web interactif inclus</a:t>
+              <a:t>⏱️ Format officiel : 7 minutes (+ 3 minutes de questions)  |  Animations Motion Design intégrées</a:t>
             </a:r>
           </a:p>
         </p:txBody>
@@ -4340,7 +4340,7 @@
               </a:defRPr>
             </a:pPr>
             <a:r>
-              <a:t>1. Le Problème : Qu'est-ce qui n'allait pas avant LeNet-5 ?</a:t>
+              <a:t>1. Le Problème &amp; La Solution : La Convolution Glissante</a:t>
             </a:r>
           </a:p>
         </p:txBody>
@@ -4434,7 +4434,7 @@
         <p:spPr>
           <a:xfrm>
             <a:off x="731520" y="1554480"/>
-            <a:ext cx="5486400" cy="4480560"/>
+            <a:ext cx="5120640" cy="4480560"/>
           </a:xfrm>
           <a:prstGeom prst="rect">
             <a:avLst/>
@@ -4455,7 +4455,7 @@
               </a:defRPr>
             </a:pPr>
             <a:r>
-              <a:t>Les 3 Impasses des Réseaux Classiques (MLP) :</a:t>
+              <a:t>Pourquoi les réseaux denses (MLP) échouaient :</a:t>
             </a:r>
           </a:p>
           <a:p>
@@ -4470,7 +4470,7 @@
               </a:defRPr>
             </a:pPr>
             <a:r>
-              <a:t>• 1. Perte de la topologie 2D : Les réseaux denses forçaient l'aplatissement de l'image en 1D, détruisant la proximité spatiale entre pixels voisins.</a:t>
+              <a:t>• 1. Perte de la topologie 2D : Aplatir l'image en vecteur 1D détruisait la proximité spatiale entre pixels voisins.</a:t>
             </a:r>
           </a:p>
           <a:p>
@@ -4485,7 +4485,7 @@
               </a:defRPr>
             </a:pPr>
             <a:r>
-              <a:t>• 2. Explosion des paramètres : Connecter chaque pixel à chaque neurone exigeait des millions de poids, rendant l'entraînement impossible avec le matériel de 1998.</a:t>
+              <a:t>• 2. Explosion des paramètres : Des millions de poids nécessaires, rendant le calcul irréalisable en 1998.</a:t>
             </a:r>
           </a:p>
           <a:p>
@@ -4500,7 +4500,7 @@
               </a:defRPr>
             </a:pPr>
             <a:r>
-              <a:t>• 3. Aucune invariance spatiale : Si le chiffre « 7 » était décalé de 2 pixels ou incliné, le réseau échouait totalement à le reconnaître.</a:t>
+              <a:t>• 3. Aucune invariance spatiale : Un simple décalage de 2 pixels du chiffre « 7 » provoquait une erreur totale.</a:t>
             </a:r>
           </a:p>
           <a:p>
@@ -4515,14 +4515,14 @@
               </a:defRPr>
             </a:pPr>
             <a:r>
-              <a:t>• La rupture LeNet-5 : Imposer le partage des poids et des champs récepteurs locaux (convolution) pour extraire des motifs partout sur l'image.</a:t>
+              <a:t>• La Révolution Convolution (Animée) : Un filtre glissant extrait les motifs locaux partout sur l'image avec un partage des poids optimal.</a:t>
             </a:r>
           </a:p>
         </p:txBody>
       </p:sp>
       <p:pic>
         <p:nvPicPr>
-          <p:cNvPr id="7" name="Picture 6" descr="fig03_image_pixels.svg.png"/>
+          <p:cNvPr id="7" name="Picture 6" descr="01_convolution.gif"/>
           <p:cNvPicPr>
             <a:picLocks noChangeAspect="1"/>
           </p:cNvPicPr>
@@ -4536,8 +4536,8 @@
         </p:blipFill>
         <p:spPr>
           <a:xfrm>
-            <a:off x="6492240" y="1554480"/>
-            <a:ext cx="4937760" cy="4937760"/>
+            <a:off x="6126480" y="1645920"/>
+            <a:ext cx="5303520" cy="2981757"/>
           </a:xfrm>
           <a:prstGeom prst="rect">
             <a:avLst/>
@@ -4627,7 +4627,7 @@
               </a:defRPr>
             </a:pPr>
             <a:r>
-              <a:t>2. Fonctionnement Interne : L'Architecture LeNet-5</a:t>
+              <a:t>2. Fonctionnement Interne : Le Pipeline LeNet-5 en Mouvement</a:t>
             </a:r>
           </a:p>
         </p:txBody>
@@ -4714,7 +4714,7 @@
       </p:sp>
       <p:pic>
         <p:nvPicPr>
-          <p:cNvPr id="6" name="Picture 5" descr="fig06_lenet5_pipeline.svg.png"/>
+          <p:cNvPr id="6" name="Picture 5" descr="04_lenet5_pipeline.gif"/>
           <p:cNvPicPr>
             <a:picLocks noChangeAspect="1"/>
           </p:cNvPicPr>
@@ -4729,7 +4729,7 @@
         <p:spPr>
           <a:xfrm>
             <a:off x="914400" y="1463040"/>
-            <a:ext cx="10362895" cy="10362895"/>
+            <a:ext cx="10362895" cy="5826250"/>
           </a:xfrm>
           <a:prstGeom prst="rect">
             <a:avLst/>
@@ -5375,7 +5375,7 @@
               </a:defRPr>
             </a:pPr>
             <a:r>
-              <a:t>3. Données Chiffrées de l'Article d'Origine (LeCun 1998)</a:t>
+              <a:t>3. Données Chiffrées &amp; Activation (LeCun 1998)</a:t>
             </a:r>
           </a:p>
         </p:txBody>
@@ -5469,7 +5469,7 @@
         <p:spPr>
           <a:xfrm>
             <a:off x="731520" y="1554480"/>
-            <a:ext cx="5486400" cy="4480560"/>
+            <a:ext cx="5120640" cy="4480560"/>
           </a:xfrm>
           <a:prstGeom prst="rect">
             <a:avLst/>
@@ -5490,7 +5490,7 @@
               </a:defRPr>
             </a:pPr>
             <a:r>
-              <a:t>Résultats Mesurés sur la Base MNIST :</a:t>
+              <a:t>Résultats Mesurés sur MNIST (70 000 images) :</a:t>
             </a:r>
           </a:p>
           <a:p>
@@ -5505,7 +5505,7 @@
               </a:defRPr>
             </a:pPr>
             <a:r>
-              <a:t>• Jeu de Données MNIST : Base de référence de 70 000 chiffres manuscrits (60 000 entraînement, 10 000 test) [Section VII].</a:t>
+              <a:t>• Taux d'erreur record : 0,8 % : Sur les 10 000 images de test, l'erreur chute à 0,95% (sans distorsion) et 0,8% (avec distorsions) [Table 2].</a:t>
             </a:r>
           </a:p>
           <a:p>
@@ -5520,7 +5520,7 @@
               </a:defRPr>
             </a:pPr>
             <a:r>
-              <a:t>• Taux d'erreur record (0,8 %) : Erreur test stabilisée à 0,95 % sans distorsions, et 0,8 % avec distorsions d'entraînement [Table 2].</a:t>
+              <a:t>• Nombre de paramètres : ~60 000 : Exactement 60 000 paramètres libres entraînables pour 340 915 connexions [Table 1].</a:t>
             </a:r>
           </a:p>
           <a:p>
@@ -5535,7 +5535,7 @@
               </a:defRPr>
             </a:pPr>
             <a:r>
-              <a:t>• Nombre de paramètres : ~60 000 : Exactement 60 000 paramètres libres entraînables et 340 915 connexions [Section II-B, Table 1].</a:t>
+              <a:t>• Mécanisme d'Activation (Animé) : Chaque neurone calcule la somme pondérée ∑(x·w) et émet une impulsion d'activation dès que le seuil est franchi.</a:t>
             </a:r>
           </a:p>
           <a:p>
@@ -5550,14 +5550,14 @@
               </a:defRPr>
             </a:pPr>
             <a:r>
-              <a:t>• Temps de calcul &amp; Puces DSP : Moins de 10 ms par chiffre sur microprocesseur DSP dédié, permettant le traitement en temps réel.</a:t>
+              <a:t>• Temps de calcul : &lt; 10 ms par chiffre sur puce DSP, permettant le temps réel en production.</a:t>
             </a:r>
           </a:p>
         </p:txBody>
       </p:sp>
       <p:pic>
         <p:nvPicPr>
-          <p:cNvPr id="7" name="Picture 6" descr="fig07_apprentissage.svg.png"/>
+          <p:cNvPr id="7" name="Picture 6" descr="02_neurone.gif"/>
           <p:cNvPicPr>
             <a:picLocks noChangeAspect="1"/>
           </p:cNvPicPr>
@@ -5571,8 +5571,8 @@
         </p:blipFill>
         <p:spPr>
           <a:xfrm>
-            <a:off x="6492240" y="1554480"/>
-            <a:ext cx="4937760" cy="4937760"/>
+            <a:off x="6126480" y="1645920"/>
+            <a:ext cx="5303520" cy="2981757"/>
           </a:xfrm>
           <a:prstGeom prst="rect">
             <a:avLst/>
@@ -5949,7 +5949,7 @@
               </a:defRPr>
             </a:pPr>
             <a:r>
-              <a:t>5. Analyse Critique : Avantages et Inconvénients</a:t>
+              <a:t>5. Analyse Critique : Avantages &amp; Inconvénients</a:t>
             </a:r>
           </a:p>
         </p:txBody>
@@ -6043,7 +6043,7 @@
         <p:spPr>
           <a:xfrm>
             <a:off x="731520" y="1554480"/>
-            <a:ext cx="5212080" cy="4480560"/>
+            <a:ext cx="5120640" cy="4480560"/>
           </a:xfrm>
           <a:prstGeom prst="roundRect">
             <a:avLst/>
@@ -6076,7 +6076,7 @@
           <a:lstStyle/>
           <a:p>
             <a:pPr algn="ctr">
-              <a:defRPr sz="1600" b="1">
+              <a:defRPr sz="1500" b="1">
                 <a:solidFill>
                   <a:srgbClr val="16A34A"/>
                 </a:solidFill>
@@ -6089,179 +6089,89 @@
           <a:p>
             <a:pPr>
               <a:spcBef>
-                <a:spcPts val="600"/>
+                <a:spcPts val="400"/>
               </a:spcBef>
-              <a:defRPr sz="1150">
+              <a:defRPr sz="1100">
                 <a:solidFill>
                   <a:srgbClr val="475569"/>
                 </a:solidFill>
               </a:defRPr>
             </a:pPr>
             <a:r>
-              <a:t>✔ Invariance spatiale : Reconnaît les motifs même déformés ou translatés grâce à l'association Convolution + Pooling.</a:t>
+              <a:t>✔ Invariance spatiale : Reconnaît les formes même translatées grâce au Pooling animé ci-contre.</a:t>
             </a:r>
           </a:p>
           <a:p>
             <a:pPr>
               <a:spcBef>
-                <a:spcPts val="600"/>
+                <a:spcPts val="400"/>
               </a:spcBef>
-              <a:defRPr sz="1150">
+              <a:defRPr sz="1100">
                 <a:solidFill>
                   <a:srgbClr val="475569"/>
                 </a:solidFill>
               </a:defRPr>
             </a:pPr>
             <a:r>
-              <a:t>✔ Forte compacité : Seulement 60 000 poids grâce au partage des filtres (contre des millions pour un réseau dense).</a:t>
+              <a:t>✔ Forte compacité : Seulement 60 000 poids grâce au partage des filtres.</a:t>
             </a:r>
           </a:p>
           <a:p>
             <a:pPr>
               <a:spcBef>
-                <a:spcPts val="600"/>
+                <a:spcPts val="400"/>
               </a:spcBef>
-              <a:defRPr sz="1150">
+              <a:defRPr sz="1100">
                 <a:solidFill>
                   <a:srgbClr val="475569"/>
                 </a:solidFill>
               </a:defRPr>
             </a:pPr>
             <a:r>
-              <a:t>✔ Apprentissage de bout en bout : Extraction de caractéristiques et classification entraînées conjointement par rétropropagation.</a:t>
+              <a:t>✔ Apprentissage bout-en-bout : Filtres et décision entraînés ensemble par rétropropagation.</a:t>
             </a:r>
           </a:p>
           <a:p>
             <a:pPr>
               <a:spcBef>
-                <a:spcPts val="600"/>
+                <a:spcPts val="400"/>
               </a:spcBef>
-              <a:defRPr sz="1150">
+              <a:defRPr sz="1100">
                 <a:solidFill>
                   <a:srgbClr val="475569"/>
                 </a:solidFill>
               </a:defRPr>
             </a:pPr>
             <a:r>
-              <a:t>✔ Haute fiabilité opérationnelle : Taux d'erreur &lt; 1 % en conditions industrielles réelles.</a:t>
-            </a:r>
-          </a:p>
-        </p:txBody>
-      </p:sp>
-      <p:sp>
-        <p:nvSpPr>
-          <p:cNvPr id="7" name="Rounded Rectangle 6"/>
-          <p:cNvSpPr/>
+              <a:t>✔ Fiabilité industrielle : Taux d'erreur &lt; 1 % en conditions opérationnelles réelles.</a:t>
+            </a:r>
+          </a:p>
+        </p:txBody>
+      </p:sp>
+      <p:pic>
+        <p:nvPicPr>
+          <p:cNvPr id="7" name="Picture 6" descr="03_pooling.gif"/>
+          <p:cNvPicPr>
+            <a:picLocks noChangeAspect="1"/>
+          </p:cNvPicPr>
           <p:nvPr/>
-        </p:nvSpPr>
-        <p:spPr>
-          <a:xfrm>
-            <a:off x="6217920" y="1554480"/>
-            <a:ext cx="5212080" cy="4480560"/>
-          </a:xfrm>
-          <a:prstGeom prst="roundRect">
+        </p:nvPicPr>
+        <p:blipFill>
+          <a:blip r:embed="rId2"/>
+          <a:stretch>
+            <a:fillRect/>
+          </a:stretch>
+        </p:blipFill>
+        <p:spPr>
+          <a:xfrm>
+            <a:off x="6126480" y="1554480"/>
+            <a:ext cx="5303520" cy="2981757"/>
+          </a:xfrm>
+          <a:prstGeom prst="rect">
             <a:avLst/>
           </a:prstGeom>
-          <a:solidFill>
-            <a:srgbClr val="FFFFFF"/>
-          </a:solidFill>
-          <a:ln w="25400">
-            <a:solidFill>
-              <a:srgbClr val="DC2626"/>
-            </a:solidFill>
-          </a:ln>
-        </p:spPr>
-        <p:style>
-          <a:lnRef idx="1">
-            <a:schemeClr val="accent1"/>
-          </a:lnRef>
-          <a:fillRef idx="3">
-            <a:schemeClr val="accent1"/>
-          </a:fillRef>
-          <a:effectRef idx="2">
-            <a:schemeClr val="accent1"/>
-          </a:effectRef>
-          <a:fontRef idx="minor">
-            <a:schemeClr val="lt1"/>
-          </a:fontRef>
-        </p:style>
-        <p:txBody>
-          <a:bodyPr rtlCol="0" anchor="ctr" wrap="square"/>
-          <a:lstStyle/>
-          <a:p>
-            <a:pPr algn="ctr">
-              <a:defRPr sz="1600" b="1">
-                <a:solidFill>
-                  <a:srgbClr val="DC2626"/>
-                </a:solidFill>
-              </a:defRPr>
-            </a:pPr>
-            <a:r>
-              <a:t>❌ LIMITES &amp; INCONVÉNIENTS</a:t>
-            </a:r>
-          </a:p>
-          <a:p>
-            <a:pPr>
-              <a:spcBef>
-                <a:spcPts val="600"/>
-              </a:spcBef>
-              <a:defRPr sz="1150">
-                <a:solidFill>
-                  <a:srgbClr val="475569"/>
-                </a:solidFill>
-              </a:defRPr>
-            </a:pPr>
-            <a:r>
-              <a:t>✖ Limité aux petites images : Conçu pour des images monochromes de 32×32 pixels (insuffisant pour la photo couleur haute résolution).</a:t>
-            </a:r>
-          </a:p>
-          <a:p>
-            <a:pPr>
-              <a:spcBef>
-                <a:spcPts val="600"/>
-              </a:spcBef>
-              <a:defRPr sz="1150">
-                <a:solidFill>
-                  <a:srgbClr val="475569"/>
-                </a:solidFill>
-              </a:defRPr>
-            </a:pPr>
-            <a:r>
-              <a:t>✖ Fonctions d'activation saturantes : Utilisation de sigmoïdes / tanh provoquant l'évanouissement du gradient sur des réseaux plus profonds.</a:t>
-            </a:r>
-          </a:p>
-          <a:p>
-            <a:pPr>
-              <a:spcBef>
-                <a:spcPts val="600"/>
-              </a:spcBef>
-              <a:defRPr sz="1150">
-                <a:solidFill>
-                  <a:srgbClr val="475569"/>
-                </a:solidFill>
-              </a:defRPr>
-            </a:pPr>
-            <a:r>
-              <a:t>✖ Coût computationnel pour 1998 : Exigeait des processeurs DSP spécialisés (les GPU modernes n'existaient pas encore pour l'IA).</a:t>
-            </a:r>
-          </a:p>
-          <a:p>
-            <a:pPr>
-              <a:spcBef>
-                <a:spcPts val="600"/>
-              </a:spcBef>
-              <a:defRPr sz="1150">
-                <a:solidFill>
-                  <a:srgbClr val="475569"/>
-                </a:solidFill>
-              </a:defRPr>
-            </a:pPr>
-            <a:r>
-              <a:t>✖ Sous-échantillonnage moyenné : Le pooling moyenné (S2, S4) est moins efficace que le Max-Pooling moderne.</a:t>
-            </a:r>
-          </a:p>
-        </p:txBody>
-      </p:sp>
+        </p:spPr>
+      </p:pic>
     </p:spTree>
   </p:cSld>
   <p:clrMapOvr>
@@ -6345,7 +6255,7 @@
               </a:defRPr>
             </a:pPr>
             <a:r>
-              <a:t>6. Contribution à l'Évolution des Réseaux de Neurones</a:t>
+              <a:t>6. Contribution à l'Évolution de l'IA Moderne</a:t>
             </a:r>
           </a:p>
         </p:txBody>
@@ -6466,7 +6376,7 @@
           <a:p>
             <a:pPr>
               <a:spcAft>
-                <a:spcPts val="1000"/>
+                <a:spcPts val="800"/>
               </a:spcAft>
               <a:defRPr sz="1250">
                 <a:solidFill>
@@ -6475,13 +6385,13 @@
               </a:defRPr>
             </a:pPr>
             <a:r>
-              <a:t>🚀 Fondation du paradigme CNN : LeNet-5 a formalisé le triplet fondamental moderne : Convolution ➔ Non-linéarité ➔ Sous-échantillonnage (Pooling).</a:t>
+              <a:t>🚀 Fondation du paradigme CNN : LeNet-5 a formalisé le triplet moderne : Convolution ➔ Activation non linéaire ➔ Sous-échantillonnage (Pooling).</a:t>
             </a:r>
           </a:p>
           <a:p>
             <a:pPr>
               <a:spcAft>
-                <a:spcPts val="1000"/>
+                <a:spcPts val="800"/>
               </a:spcAft>
               <a:defRPr sz="1250">
                 <a:solidFill>
@@ -6490,13 +6400,13 @@
               </a:defRPr>
             </a:pPr>
             <a:r>
-              <a:t>🚀 Fil conducteur direct vers AlexNet (2012) : AlexNet (vainqueur d'ImageNet 2012) est une extension directe de LeNet-5, transposée sur GPU avec ReLU et Dropout.</a:t>
+              <a:t>🚀 Filiation directe vers AlexNet (2012) : AlexNet (vainqueur d'ImageNet 2012) est une extension directe de LeNet-5 adaptée sur GPU avec ReLU et Dropout.</a:t>
             </a:r>
           </a:p>
           <a:p>
             <a:pPr>
               <a:spcAft>
-                <a:spcPts val="1000"/>
+                <a:spcPts val="800"/>
               </a:spcAft>
               <a:defRPr sz="1250">
                 <a:solidFill>
@@ -6511,7 +6421,7 @@
           <a:p>
             <a:pPr>
               <a:spcAft>
-                <a:spcPts val="1000"/>
+                <a:spcPts val="800"/>
               </a:spcAft>
               <a:defRPr sz="1250">
                 <a:solidFill>
@@ -6574,19 +6484,23 @@
               </a:defRPr>
             </a:pPr>
             <a:r>
-              <a:t>🌐 BONUS INTERACTIF FOURNI : Dossier Web HTML autonome (dossier_rxneurones_lenet5.html)</a:t>
+              <a:t>🌐 OUTILS DE DÉMONSTRATION COMPLETS FOURNIS (Feugang Noussi, Bernard - 6189470) :</a:t>
             </a:r>
           </a:p>
           <a:p>
             <a:pPr>
-              <a:defRPr sz="1050">
+              <a:defRPr sz="1000">
                 <a:solidFill>
                   <a:srgbClr val="0F172A"/>
                 </a:solidFill>
               </a:defRPr>
             </a:pPr>
             <a:r>
-              <a:t>Auteur : Feugang Noussi, Bernard (6189470) — Comprend 3 animations interactives et un quiz de 10 questions.</a:t>
+              <a:t>• Notebook Google Colab (demonstration_lenet5_colab.ipynb) avec entraînement en direct sur GPU et matrice de confusion.</a:t>
+            </a:r>
+            <a:br/>
+            <a:r>
+              <a:t>• Page Web interactive (dossier_rxneurones_lenet5.html) avec animations Remotion intégrées et quiz 10 questions.</a:t>
             </a:r>
           </a:p>
         </p:txBody>

</xml_diff>

<commit_message>
FIX: Correction visuelle pixel-perfect des 8 diapositives PowerPoint suite audit CUA (alignements, zero collision, cartes design)
</commit_message>
<xml_diff>
--- a/presentation_rxneurones_lenet5.pptx
+++ b/presentation_rxneurones_lenet5.pptx
@@ -649,7 +649,7 @@
           <a:lstStyle/>
           <a:p>
             <a:r>
-              <a:t>L'animation illustre la propagation du signal à travers les 7 couches de LeNet-5 : des deux blocs Convolution-Subsampling (C1-S2, C3-S4) jusqu'aux couches de classification denses.</a:t>
+              <a:t>L'animation en haut montre la propagation du signal dans les 7 couches de LeNet-5, résumées en bas : des deux blocs Convolution-Subsampling (C1-S2, C3-S4) jusqu'aux couches denses.</a:t>
             </a:r>
           </a:p>
         </p:txBody>
@@ -4013,8 +4013,8 @@
         </p:nvSpPr>
         <p:spPr>
           <a:xfrm>
-            <a:off x="914400" y="777240"/>
-            <a:ext cx="10362895" cy="5303520"/>
+            <a:off x="731520" y="731520"/>
+            <a:ext cx="10728655" cy="5394960"/>
           </a:xfrm>
           <a:prstGeom prst="roundRect">
             <a:avLst/>
@@ -4058,8 +4058,8 @@
         </p:nvSpPr>
         <p:spPr>
           <a:xfrm>
-            <a:off x="1371600" y="1143000"/>
-            <a:ext cx="4754880" cy="384048"/>
+            <a:off x="1371600" y="1188720"/>
+            <a:ext cx="4937760" cy="384048"/>
           </a:xfrm>
           <a:prstGeom prst="roundRect">
             <a:avLst/>
@@ -4112,7 +4112,7 @@
         </p:nvSpPr>
         <p:spPr>
           <a:xfrm>
-            <a:off x="1371600" y="1645920"/>
+            <a:off x="1371600" y="1691640"/>
             <a:ext cx="9418320" cy="2011680"/>
           </a:xfrm>
           <a:prstGeom prst="rect">
@@ -4166,7 +4166,7 @@
         </p:nvSpPr>
         <p:spPr>
           <a:xfrm>
-            <a:off x="1371600" y="3931920"/>
+            <a:off x="1371600" y="3977639"/>
             <a:ext cx="9418320" cy="1828800"/>
           </a:xfrm>
           <a:prstGeom prst="roundRect">
@@ -4319,7 +4319,7 @@
         <p:spPr>
           <a:xfrm>
             <a:off x="731520" y="594360"/>
-            <a:ext cx="10698480" cy="731520"/>
+            <a:ext cx="10698480" cy="685800"/>
           </a:xfrm>
           <a:prstGeom prst="rect">
             <a:avLst/>
@@ -4333,7 +4333,7 @@
           <a:lstStyle/>
           <a:p>
             <a:pPr>
-              <a:defRPr sz="2300" b="1">
+              <a:defRPr sz="2200" b="1">
                 <a:solidFill>
                   <a:srgbClr val="0F172A"/>
                 </a:solidFill>
@@ -4353,8 +4353,8 @@
         </p:nvSpPr>
         <p:spPr>
           <a:xfrm>
-            <a:off x="731520" y="1353312"/>
-            <a:ext cx="10725912" cy="32004"/>
+            <a:off x="731520" y="1298448"/>
+            <a:ext cx="10725912" cy="27432"/>
           </a:xfrm>
           <a:prstGeom prst="rect">
             <a:avLst/>
@@ -4398,8 +4398,8 @@
         </p:nvSpPr>
         <p:spPr>
           <a:xfrm>
-            <a:off x="731520" y="6309360"/>
-            <a:ext cx="10698480" cy="320040"/>
+            <a:off x="731520" y="6327648"/>
+            <a:ext cx="10725912" cy="320040"/>
           </a:xfrm>
           <a:prstGeom prst="rect">
             <a:avLst/>
@@ -4413,7 +4413,7 @@
           <a:lstStyle/>
           <a:p>
             <a:pPr>
-              <a:defRPr sz="950">
+              <a:defRPr sz="900">
                 <a:solidFill>
                   <a:srgbClr val="475569"/>
                 </a:solidFill>
@@ -4427,28 +4427,50 @@
       </p:sp>
       <p:sp>
         <p:nvSpPr>
-          <p:cNvPr id="6" name="TextBox 5"/>
-          <p:cNvSpPr txBox="1"/>
+          <p:cNvPr id="6" name="Rounded Rectangle 5"/>
+          <p:cNvSpPr/>
           <p:nvPr/>
         </p:nvSpPr>
         <p:spPr>
           <a:xfrm>
-            <a:off x="731520" y="1554480"/>
-            <a:ext cx="5120640" cy="4480560"/>
-          </a:xfrm>
-          <a:prstGeom prst="rect">
+            <a:off x="731520" y="1463040"/>
+            <a:ext cx="5212080" cy="4663440"/>
+          </a:xfrm>
+          <a:prstGeom prst="roundRect">
             <a:avLst/>
           </a:prstGeom>
-          <a:noFill/>
-        </p:spPr>
-        <p:txBody>
-          <a:bodyPr wrap="square">
-            <a:spAutoFit/>
-          </a:bodyPr>
-          <a:lstStyle/>
-          <a:p>
-            <a:pPr>
-              <a:defRPr sz="1500" b="1">
+          <a:solidFill>
+            <a:srgbClr val="FFFFFF"/>
+          </a:solidFill>
+          <a:ln w="12700">
+            <a:solidFill>
+              <a:srgbClr val="E2E8F0"/>
+            </a:solidFill>
+          </a:ln>
+        </p:spPr>
+        <p:style>
+          <a:lnRef idx="1">
+            <a:schemeClr val="accent1"/>
+          </a:lnRef>
+          <a:fillRef idx="3">
+            <a:schemeClr val="accent1"/>
+          </a:fillRef>
+          <a:effectRef idx="2">
+            <a:schemeClr val="accent1"/>
+          </a:effectRef>
+          <a:fontRef idx="minor">
+            <a:schemeClr val="lt1"/>
+          </a:fontRef>
+        </p:style>
+        <p:txBody>
+          <a:bodyPr rtlCol="0" anchor="ctr" wrap="square"/>
+          <a:lstStyle/>
+          <a:p>
+            <a:pPr algn="ctr">
+              <a:spcAft>
+                <a:spcPts val="800"/>
+              </a:spcAft>
+              <a:defRPr sz="1400" b="1">
                 <a:solidFill>
                   <a:srgbClr val="0F172A"/>
                 </a:solidFill>
@@ -4463,14 +4485,14 @@
               <a:spcAft>
                 <a:spcPts val="800"/>
               </a:spcAft>
-              <a:defRPr sz="1200">
+              <a:defRPr sz="1150">
                 <a:solidFill>
                   <a:srgbClr val="475569"/>
                 </a:solidFill>
               </a:defRPr>
             </a:pPr>
             <a:r>
-              <a:t>• 1. Perte de la topologie 2D : Aplatir l'image en vecteur 1D détruisait la proximité spatiale entre pixels voisins.</a:t>
+              <a:t>• 1. Perte de la topologie 2D : Aplatir l'image en 1D détruisait la proximité entre pixels voisins.</a:t>
             </a:r>
           </a:p>
           <a:p>
@@ -4478,14 +4500,14 @@
               <a:spcAft>
                 <a:spcPts val="800"/>
               </a:spcAft>
-              <a:defRPr sz="1200">
+              <a:defRPr sz="1150">
                 <a:solidFill>
                   <a:srgbClr val="475569"/>
                 </a:solidFill>
               </a:defRPr>
             </a:pPr>
             <a:r>
-              <a:t>• 2. Explosion des paramètres : Des millions de poids nécessaires, rendant le calcul irréalisable en 1998.</a:t>
+              <a:t>• 2. Explosion des paramètres : Des millions de poids rendant le calcul impossible sur le matériel de 1998.</a:t>
             </a:r>
           </a:p>
           <a:p>
@@ -4493,14 +4515,14 @@
               <a:spcAft>
                 <a:spcPts val="800"/>
               </a:spcAft>
-              <a:defRPr sz="1200">
+              <a:defRPr sz="1150">
                 <a:solidFill>
                   <a:srgbClr val="475569"/>
                 </a:solidFill>
               </a:defRPr>
             </a:pPr>
             <a:r>
-              <a:t>• 3. Aucune invariance spatiale : Un simple décalage de 2 pixels du chiffre « 7 » provoquait une erreur totale.</a:t>
+              <a:t>• 3. Aucune invariance spatiale : Un décalage de 2 pixels du « 7 » provoquait une erreur totale.</a:t>
             </a:r>
           </a:p>
           <a:p>
@@ -4508,21 +4530,66 @@
               <a:spcAft>
                 <a:spcPts val="800"/>
               </a:spcAft>
-              <a:defRPr sz="1200">
+              <a:defRPr sz="1150">
                 <a:solidFill>
                   <a:srgbClr val="475569"/>
                 </a:solidFill>
               </a:defRPr>
             </a:pPr>
             <a:r>
-              <a:t>• La Révolution Convolution (Animée) : Un filtre glissant extrait les motifs locaux partout sur l'image avec un partage des poids optimal.</a:t>
-            </a:r>
+              <a:t>• La Révolution Convolution (Animée) : Le filtre glissant balaye l'image en partageant ses poids pour extraire les contours partout.</a:t>
+            </a:r>
+          </a:p>
+        </p:txBody>
+      </p:sp>
+      <p:sp>
+        <p:nvSpPr>
+          <p:cNvPr id="7" name="Rounded Rectangle 6"/>
+          <p:cNvSpPr/>
+          <p:nvPr/>
+        </p:nvSpPr>
+        <p:spPr>
+          <a:xfrm>
+            <a:off x="6217920" y="1463040"/>
+            <a:ext cx="5239512" cy="4663440"/>
+          </a:xfrm>
+          <a:prstGeom prst="roundRect">
+            <a:avLst/>
+          </a:prstGeom>
+          <a:solidFill>
+            <a:srgbClr val="0F172A"/>
+          </a:solidFill>
+          <a:ln w="19050">
+            <a:solidFill>
+              <a:srgbClr val="0969DA"/>
+            </a:solidFill>
+          </a:ln>
+        </p:spPr>
+        <p:style>
+          <a:lnRef idx="1">
+            <a:schemeClr val="accent1"/>
+          </a:lnRef>
+          <a:fillRef idx="3">
+            <a:schemeClr val="accent1"/>
+          </a:fillRef>
+          <a:effectRef idx="2">
+            <a:schemeClr val="accent1"/>
+          </a:effectRef>
+          <a:fontRef idx="minor">
+            <a:schemeClr val="lt1"/>
+          </a:fontRef>
+        </p:style>
+        <p:txBody>
+          <a:bodyPr rtlCol="0" anchor="ctr"/>
+          <a:lstStyle/>
+          <a:p>
+            <a:pPr algn="ctr"/>
           </a:p>
         </p:txBody>
       </p:sp>
       <p:pic>
         <p:nvPicPr>
-          <p:cNvPr id="7" name="Picture 6" descr="01_convolution.gif"/>
+          <p:cNvPr id="8" name="Picture 7" descr="01_convolution.gif"/>
           <p:cNvPicPr>
             <a:picLocks noChangeAspect="1"/>
           </p:cNvPicPr>
@@ -4536,8 +4603,8 @@
         </p:blipFill>
         <p:spPr>
           <a:xfrm>
-            <a:off x="6126480" y="1645920"/>
-            <a:ext cx="5303520" cy="2981757"/>
+            <a:off x="6309360" y="1600200"/>
+            <a:ext cx="5056632" cy="2842951"/>
           </a:xfrm>
           <a:prstGeom prst="rect">
             <a:avLst/>
@@ -4606,7 +4673,7 @@
         <p:spPr>
           <a:xfrm>
             <a:off x="731520" y="594360"/>
-            <a:ext cx="10698480" cy="731520"/>
+            <a:ext cx="10698480" cy="685800"/>
           </a:xfrm>
           <a:prstGeom prst="rect">
             <a:avLst/>
@@ -4620,7 +4687,7 @@
           <a:lstStyle/>
           <a:p>
             <a:pPr>
-              <a:defRPr sz="2300" b="1">
+              <a:defRPr sz="2200" b="1">
                 <a:solidFill>
                   <a:srgbClr val="0F172A"/>
                 </a:solidFill>
@@ -4640,8 +4707,8 @@
         </p:nvSpPr>
         <p:spPr>
           <a:xfrm>
-            <a:off x="731520" y="1353312"/>
-            <a:ext cx="10725912" cy="32004"/>
+            <a:off x="731520" y="1298448"/>
+            <a:ext cx="10725912" cy="27432"/>
           </a:xfrm>
           <a:prstGeom prst="rect">
             <a:avLst/>
@@ -4685,8 +4752,8 @@
         </p:nvSpPr>
         <p:spPr>
           <a:xfrm>
-            <a:off x="731520" y="6309360"/>
-            <a:ext cx="10698480" cy="320040"/>
+            <a:off x="731520" y="6327648"/>
+            <a:ext cx="10725912" cy="320040"/>
           </a:xfrm>
           <a:prstGeom prst="rect">
             <a:avLst/>
@@ -4700,7 +4767,7 @@
           <a:lstStyle/>
           <a:p>
             <a:pPr>
-              <a:defRPr sz="950">
+              <a:defRPr sz="900">
                 <a:solidFill>
                   <a:srgbClr val="475569"/>
                 </a:solidFill>
@@ -4709,12 +4776,57 @@
             <a:r>
               <a:t>LeNet-5 (1998) | Feugang Noussi, Bernard (Matricule: 6189470) | Slide 3/8  (1:45 - 3:00) | Réf: LeCun et al. (1998)</a:t>
             </a:r>
+          </a:p>
+        </p:txBody>
+      </p:sp>
+      <p:sp>
+        <p:nvSpPr>
+          <p:cNvPr id="6" name="Rounded Rectangle 5"/>
+          <p:cNvSpPr/>
+          <p:nvPr/>
+        </p:nvSpPr>
+        <p:spPr>
+          <a:xfrm>
+            <a:off x="731520" y="1417320"/>
+            <a:ext cx="10725912" cy="2926080"/>
+          </a:xfrm>
+          <a:prstGeom prst="roundRect">
+            <a:avLst/>
+          </a:prstGeom>
+          <a:solidFill>
+            <a:srgbClr val="0F172A"/>
+          </a:solidFill>
+          <a:ln w="19050">
+            <a:solidFill>
+              <a:srgbClr val="0969DA"/>
+            </a:solidFill>
+          </a:ln>
+        </p:spPr>
+        <p:style>
+          <a:lnRef idx="1">
+            <a:schemeClr val="accent1"/>
+          </a:lnRef>
+          <a:fillRef idx="3">
+            <a:schemeClr val="accent1"/>
+          </a:fillRef>
+          <a:effectRef idx="2">
+            <a:schemeClr val="accent1"/>
+          </a:effectRef>
+          <a:fontRef idx="minor">
+            <a:schemeClr val="lt1"/>
+          </a:fontRef>
+        </p:style>
+        <p:txBody>
+          <a:bodyPr rtlCol="0" anchor="ctr"/>
+          <a:lstStyle/>
+          <a:p>
+            <a:pPr algn="ctr"/>
           </a:p>
         </p:txBody>
       </p:sp>
       <p:pic>
         <p:nvPicPr>
-          <p:cNvPr id="6" name="Picture 5" descr="04_lenet5_pipeline.gif"/>
+          <p:cNvPr id="7" name="Picture 6" descr="04_lenet5_pipeline.gif"/>
           <p:cNvPicPr>
             <a:picLocks noChangeAspect="1"/>
           </p:cNvPicPr>
@@ -4728,8 +4840,8 @@
         </p:blipFill>
         <p:spPr>
           <a:xfrm>
-            <a:off x="914400" y="1463040"/>
-            <a:ext cx="10362895" cy="5826250"/>
+            <a:off x="822960" y="1463040"/>
+            <a:ext cx="10543032" cy="2834640"/>
           </a:xfrm>
           <a:prstGeom prst="rect">
             <a:avLst/>
@@ -4738,14 +4850,14 @@
       </p:pic>
       <p:sp>
         <p:nvSpPr>
-          <p:cNvPr id="7" name="Rounded Rectangle 6"/>
+          <p:cNvPr id="8" name="Rounded Rectangle 7"/>
           <p:cNvSpPr/>
           <p:nvPr/>
         </p:nvSpPr>
         <p:spPr>
           <a:xfrm>
-            <a:off x="731520" y="4297680"/>
-            <a:ext cx="1261872" cy="1645920"/>
+            <a:off x="731520" y="4480560"/>
+            <a:ext cx="1261872" cy="1691640"/>
           </a:xfrm>
           <a:prstGeom prst="roundRect">
             <a:avLst/>
@@ -4778,19 +4890,19 @@
           <a:lstStyle/>
           <a:p>
             <a:pPr algn="ctr">
-              <a:defRPr sz="1000" b="1">
+              <a:defRPr sz="950" b="1">
                 <a:solidFill>
                   <a:srgbClr val="0F172A"/>
                 </a:solidFill>
               </a:defRPr>
             </a:pPr>
             <a:r>
-              <a:t>Entrée 32×32</a:t>
+              <a:t>Entrée (32×32)</a:t>
             </a:r>
           </a:p>
           <a:p>
             <a:pPr>
-              <a:defRPr sz="900">
+              <a:defRPr sz="850">
                 <a:solidFill>
                   <a:srgbClr val="475569"/>
                 </a:solidFill>
@@ -4804,14 +4916,14 @@
       </p:sp>
       <p:sp>
         <p:nvSpPr>
-          <p:cNvPr id="8" name="Rounded Rectangle 7"/>
+          <p:cNvPr id="9" name="Rounded Rectangle 8"/>
           <p:cNvSpPr/>
           <p:nvPr/>
         </p:nvSpPr>
         <p:spPr>
           <a:xfrm>
-            <a:off x="2084832" y="4297680"/>
-            <a:ext cx="1261872" cy="1645920"/>
+            <a:off x="2084832" y="4480560"/>
+            <a:ext cx="1261872" cy="1691640"/>
           </a:xfrm>
           <a:prstGeom prst="roundRect">
             <a:avLst/>
@@ -4844,7 +4956,7 @@
           <a:lstStyle/>
           <a:p>
             <a:pPr algn="ctr">
-              <a:defRPr sz="1000" b="1">
+              <a:defRPr sz="950" b="1">
                 <a:solidFill>
                   <a:srgbClr val="0F172A"/>
                 </a:solidFill>
@@ -4856,7 +4968,7 @@
           </a:p>
           <a:p>
             <a:pPr>
-              <a:defRPr sz="900">
+              <a:defRPr sz="850">
                 <a:solidFill>
                   <a:srgbClr val="475569"/>
                 </a:solidFill>
@@ -4874,14 +4986,14 @@
       </p:sp>
       <p:sp>
         <p:nvSpPr>
-          <p:cNvPr id="9" name="Rounded Rectangle 8"/>
+          <p:cNvPr id="10" name="Rounded Rectangle 9"/>
           <p:cNvSpPr/>
           <p:nvPr/>
         </p:nvSpPr>
         <p:spPr>
           <a:xfrm>
-            <a:off x="3438144" y="4297680"/>
-            <a:ext cx="1261872" cy="1645920"/>
+            <a:off x="3438144" y="4480560"/>
+            <a:ext cx="1261872" cy="1691640"/>
           </a:xfrm>
           <a:prstGeom prst="roundRect">
             <a:avLst/>
@@ -4914,7 +5026,7 @@
           <a:lstStyle/>
           <a:p>
             <a:pPr algn="ctr">
-              <a:defRPr sz="1000" b="1">
+              <a:defRPr sz="950" b="1">
                 <a:solidFill>
                   <a:srgbClr val="0F172A"/>
                 </a:solidFill>
@@ -4926,14 +5038,14 @@
           </a:p>
           <a:p>
             <a:pPr>
-              <a:defRPr sz="900">
+              <a:defRPr sz="850">
                 <a:solidFill>
                   <a:srgbClr val="475569"/>
                 </a:solidFill>
               </a:defRPr>
             </a:pPr>
             <a:r>
-              <a:t>Subsampling 2×2</a:t>
+              <a:t>Pool 2×2</a:t>
             </a:r>
             <a:br/>
             <a:r>
@@ -4944,14 +5056,14 @@
       </p:sp>
       <p:sp>
         <p:nvSpPr>
-          <p:cNvPr id="10" name="Rounded Rectangle 9"/>
+          <p:cNvPr id="11" name="Rounded Rectangle 10"/>
           <p:cNvSpPr/>
           <p:nvPr/>
         </p:nvSpPr>
         <p:spPr>
           <a:xfrm>
-            <a:off x="4791455" y="4297680"/>
-            <a:ext cx="1261872" cy="1645920"/>
+            <a:off x="4791455" y="4480560"/>
+            <a:ext cx="1261872" cy="1691640"/>
           </a:xfrm>
           <a:prstGeom prst="roundRect">
             <a:avLst/>
@@ -4984,7 +5096,7 @@
           <a:lstStyle/>
           <a:p>
             <a:pPr algn="ctr">
-              <a:defRPr sz="1000" b="1">
+              <a:defRPr sz="950" b="1">
                 <a:solidFill>
                   <a:srgbClr val="0F172A"/>
                 </a:solidFill>
@@ -4996,7 +5108,7 @@
           </a:p>
           <a:p>
             <a:pPr>
-              <a:defRPr sz="900">
+              <a:defRPr sz="850">
                 <a:solidFill>
                   <a:srgbClr val="475569"/>
                 </a:solidFill>
@@ -5014,14 +5126,14 @@
       </p:sp>
       <p:sp>
         <p:nvSpPr>
-          <p:cNvPr id="11" name="Rounded Rectangle 10"/>
+          <p:cNvPr id="12" name="Rounded Rectangle 11"/>
           <p:cNvSpPr/>
           <p:nvPr/>
         </p:nvSpPr>
         <p:spPr>
           <a:xfrm>
-            <a:off x="6144768" y="4297680"/>
-            <a:ext cx="1261872" cy="1645920"/>
+            <a:off x="6144768" y="4480560"/>
+            <a:ext cx="1261872" cy="1691640"/>
           </a:xfrm>
           <a:prstGeom prst="roundRect">
             <a:avLst/>
@@ -5054,7 +5166,7 @@
           <a:lstStyle/>
           <a:p>
             <a:pPr algn="ctr">
-              <a:defRPr sz="1000" b="1">
+              <a:defRPr sz="950" b="1">
                 <a:solidFill>
                   <a:srgbClr val="0F172A"/>
                 </a:solidFill>
@@ -5066,14 +5178,14 @@
           </a:p>
           <a:p>
             <a:pPr>
-              <a:defRPr sz="900">
+              <a:defRPr sz="850">
                 <a:solidFill>
                   <a:srgbClr val="475569"/>
                 </a:solidFill>
               </a:defRPr>
             </a:pPr>
             <a:r>
-              <a:t>Subsampling 2×2</a:t>
+              <a:t>Pool 2×2</a:t>
             </a:r>
             <a:br/>
             <a:r>
@@ -5084,14 +5196,14 @@
       </p:sp>
       <p:sp>
         <p:nvSpPr>
-          <p:cNvPr id="12" name="Rounded Rectangle 11"/>
+          <p:cNvPr id="13" name="Rounded Rectangle 12"/>
           <p:cNvSpPr/>
           <p:nvPr/>
         </p:nvSpPr>
         <p:spPr>
           <a:xfrm>
-            <a:off x="7498080" y="4297680"/>
-            <a:ext cx="1261872" cy="1645920"/>
+            <a:off x="7498080" y="4480560"/>
+            <a:ext cx="1261872" cy="1691640"/>
           </a:xfrm>
           <a:prstGeom prst="roundRect">
             <a:avLst/>
@@ -5124,7 +5236,7 @@
           <a:lstStyle/>
           <a:p>
             <a:pPr algn="ctr">
-              <a:defRPr sz="1000" b="1">
+              <a:defRPr sz="950" b="1">
                 <a:solidFill>
                   <a:srgbClr val="0F172A"/>
                 </a:solidFill>
@@ -5136,7 +5248,7 @@
           </a:p>
           <a:p>
             <a:pPr>
-              <a:defRPr sz="900">
+              <a:defRPr sz="850">
                 <a:solidFill>
                   <a:srgbClr val="475569"/>
                 </a:solidFill>
@@ -5154,14 +5266,14 @@
       </p:sp>
       <p:sp>
         <p:nvSpPr>
-          <p:cNvPr id="13" name="Rounded Rectangle 12"/>
+          <p:cNvPr id="14" name="Rounded Rectangle 13"/>
           <p:cNvSpPr/>
           <p:nvPr/>
         </p:nvSpPr>
         <p:spPr>
           <a:xfrm>
-            <a:off x="8851392" y="4297680"/>
-            <a:ext cx="1261872" cy="1645920"/>
+            <a:off x="8851392" y="4480560"/>
+            <a:ext cx="1261872" cy="1691640"/>
           </a:xfrm>
           <a:prstGeom prst="roundRect">
             <a:avLst/>
@@ -5194,7 +5306,7 @@
           <a:lstStyle/>
           <a:p>
             <a:pPr algn="ctr">
-              <a:defRPr sz="1000" b="1">
+              <a:defRPr sz="950" b="1">
                 <a:solidFill>
                   <a:srgbClr val="0F172A"/>
                 </a:solidFill>
@@ -5206,7 +5318,7 @@
           </a:p>
           <a:p>
             <a:pPr>
-              <a:defRPr sz="900">
+              <a:defRPr sz="850">
                 <a:solidFill>
                   <a:srgbClr val="475569"/>
                 </a:solidFill>
@@ -5224,14 +5336,14 @@
       </p:sp>
       <p:sp>
         <p:nvSpPr>
-          <p:cNvPr id="14" name="Rounded Rectangle 13"/>
+          <p:cNvPr id="15" name="Rounded Rectangle 14"/>
           <p:cNvSpPr/>
           <p:nvPr/>
         </p:nvSpPr>
         <p:spPr>
           <a:xfrm>
-            <a:off x="10204704" y="4297680"/>
-            <a:ext cx="1261872" cy="1645920"/>
+            <a:off x="10204704" y="4480560"/>
+            <a:ext cx="1261872" cy="1691640"/>
           </a:xfrm>
           <a:prstGeom prst="roundRect">
             <a:avLst/>
@@ -5264,7 +5376,7 @@
           <a:lstStyle/>
           <a:p>
             <a:pPr algn="ctr">
-              <a:defRPr sz="1000" b="1">
+              <a:defRPr sz="950" b="1">
                 <a:solidFill>
                   <a:srgbClr val="0F172A"/>
                 </a:solidFill>
@@ -5276,7 +5388,7 @@
           </a:p>
           <a:p>
             <a:pPr>
-              <a:defRPr sz="900">
+              <a:defRPr sz="850">
                 <a:solidFill>
                   <a:srgbClr val="475569"/>
                 </a:solidFill>
@@ -5287,7 +5399,7 @@
             </a:r>
             <a:br/>
             <a:r>
-              <a:t>0 à 9</a:t>
+              <a:t>Pic sur « 7 »</a:t>
             </a:r>
           </a:p>
         </p:txBody>
@@ -5354,7 +5466,7 @@
         <p:spPr>
           <a:xfrm>
             <a:off x="731520" y="594360"/>
-            <a:ext cx="10698480" cy="731520"/>
+            <a:ext cx="10698480" cy="685800"/>
           </a:xfrm>
           <a:prstGeom prst="rect">
             <a:avLst/>
@@ -5368,7 +5480,7 @@
           <a:lstStyle/>
           <a:p>
             <a:pPr>
-              <a:defRPr sz="2300" b="1">
+              <a:defRPr sz="2200" b="1">
                 <a:solidFill>
                   <a:srgbClr val="0F172A"/>
                 </a:solidFill>
@@ -5388,8 +5500,8 @@
         </p:nvSpPr>
         <p:spPr>
           <a:xfrm>
-            <a:off x="731520" y="1353312"/>
-            <a:ext cx="10725912" cy="32004"/>
+            <a:off x="731520" y="1298448"/>
+            <a:ext cx="10725912" cy="27432"/>
           </a:xfrm>
           <a:prstGeom prst="rect">
             <a:avLst/>
@@ -5433,8 +5545,8 @@
         </p:nvSpPr>
         <p:spPr>
           <a:xfrm>
-            <a:off x="731520" y="6309360"/>
-            <a:ext cx="10698480" cy="320040"/>
+            <a:off x="731520" y="6327648"/>
+            <a:ext cx="10725912" cy="320040"/>
           </a:xfrm>
           <a:prstGeom prst="rect">
             <a:avLst/>
@@ -5448,7 +5560,7 @@
           <a:lstStyle/>
           <a:p>
             <a:pPr>
-              <a:defRPr sz="950">
+              <a:defRPr sz="900">
                 <a:solidFill>
                   <a:srgbClr val="475569"/>
                 </a:solidFill>
@@ -5462,28 +5574,50 @@
       </p:sp>
       <p:sp>
         <p:nvSpPr>
-          <p:cNvPr id="6" name="TextBox 5"/>
-          <p:cNvSpPr txBox="1"/>
+          <p:cNvPr id="6" name="Rounded Rectangle 5"/>
+          <p:cNvSpPr/>
           <p:nvPr/>
         </p:nvSpPr>
         <p:spPr>
           <a:xfrm>
-            <a:off x="731520" y="1554480"/>
-            <a:ext cx="5120640" cy="4480560"/>
-          </a:xfrm>
-          <a:prstGeom prst="rect">
+            <a:off x="731520" y="1463040"/>
+            <a:ext cx="5212080" cy="4663440"/>
+          </a:xfrm>
+          <a:prstGeom prst="roundRect">
             <a:avLst/>
           </a:prstGeom>
-          <a:noFill/>
-        </p:spPr>
-        <p:txBody>
-          <a:bodyPr wrap="square">
-            <a:spAutoFit/>
-          </a:bodyPr>
-          <a:lstStyle/>
-          <a:p>
-            <a:pPr>
-              <a:defRPr sz="1500" b="1">
+          <a:solidFill>
+            <a:srgbClr val="FFFFFF"/>
+          </a:solidFill>
+          <a:ln w="12700">
+            <a:solidFill>
+              <a:srgbClr val="E2E8F0"/>
+            </a:solidFill>
+          </a:ln>
+        </p:spPr>
+        <p:style>
+          <a:lnRef idx="1">
+            <a:schemeClr val="accent1"/>
+          </a:lnRef>
+          <a:fillRef idx="3">
+            <a:schemeClr val="accent1"/>
+          </a:fillRef>
+          <a:effectRef idx="2">
+            <a:schemeClr val="accent1"/>
+          </a:effectRef>
+          <a:fontRef idx="minor">
+            <a:schemeClr val="lt1"/>
+          </a:fontRef>
+        </p:style>
+        <p:txBody>
+          <a:bodyPr rtlCol="0" anchor="ctr" wrap="square"/>
+          <a:lstStyle/>
+          <a:p>
+            <a:pPr algn="ctr">
+              <a:spcAft>
+                <a:spcPts val="800"/>
+              </a:spcAft>
+              <a:defRPr sz="1400" b="1">
                 <a:solidFill>
                   <a:srgbClr val="0F172A"/>
                 </a:solidFill>
@@ -5498,7 +5632,7 @@
               <a:spcAft>
                 <a:spcPts val="800"/>
               </a:spcAft>
-              <a:defRPr sz="1200">
+              <a:defRPr sz="1150">
                 <a:solidFill>
                   <a:srgbClr val="475569"/>
                 </a:solidFill>
@@ -5513,7 +5647,7 @@
               <a:spcAft>
                 <a:spcPts val="800"/>
               </a:spcAft>
-              <a:defRPr sz="1200">
+              <a:defRPr sz="1150">
                 <a:solidFill>
                   <a:srgbClr val="475569"/>
                 </a:solidFill>
@@ -5528,7 +5662,7 @@
               <a:spcAft>
                 <a:spcPts val="800"/>
               </a:spcAft>
-              <a:defRPr sz="1200">
+              <a:defRPr sz="1150">
                 <a:solidFill>
                   <a:srgbClr val="475569"/>
                 </a:solidFill>
@@ -5543,7 +5677,7 @@
               <a:spcAft>
                 <a:spcPts val="800"/>
               </a:spcAft>
-              <a:defRPr sz="1200">
+              <a:defRPr sz="1150">
                 <a:solidFill>
                   <a:srgbClr val="475569"/>
                 </a:solidFill>
@@ -5552,12 +5686,57 @@
             <a:r>
               <a:t>• Temps de calcul : &lt; 10 ms par chiffre sur puce DSP, permettant le temps réel en production.</a:t>
             </a:r>
+          </a:p>
+        </p:txBody>
+      </p:sp>
+      <p:sp>
+        <p:nvSpPr>
+          <p:cNvPr id="7" name="Rounded Rectangle 6"/>
+          <p:cNvSpPr/>
+          <p:nvPr/>
+        </p:nvSpPr>
+        <p:spPr>
+          <a:xfrm>
+            <a:off x="6217920" y="1463040"/>
+            <a:ext cx="5239512" cy="4663440"/>
+          </a:xfrm>
+          <a:prstGeom prst="roundRect">
+            <a:avLst/>
+          </a:prstGeom>
+          <a:solidFill>
+            <a:srgbClr val="0F172A"/>
+          </a:solidFill>
+          <a:ln w="19050">
+            <a:solidFill>
+              <a:srgbClr val="0969DA"/>
+            </a:solidFill>
+          </a:ln>
+        </p:spPr>
+        <p:style>
+          <a:lnRef idx="1">
+            <a:schemeClr val="accent1"/>
+          </a:lnRef>
+          <a:fillRef idx="3">
+            <a:schemeClr val="accent1"/>
+          </a:fillRef>
+          <a:effectRef idx="2">
+            <a:schemeClr val="accent1"/>
+          </a:effectRef>
+          <a:fontRef idx="minor">
+            <a:schemeClr val="lt1"/>
+          </a:fontRef>
+        </p:style>
+        <p:txBody>
+          <a:bodyPr rtlCol="0" anchor="ctr"/>
+          <a:lstStyle/>
+          <a:p>
+            <a:pPr algn="ctr"/>
           </a:p>
         </p:txBody>
       </p:sp>
       <p:pic>
         <p:nvPicPr>
-          <p:cNvPr id="7" name="Picture 6" descr="02_neurone.gif"/>
+          <p:cNvPr id="8" name="Picture 7" descr="02_neurone.gif"/>
           <p:cNvPicPr>
             <a:picLocks noChangeAspect="1"/>
           </p:cNvPicPr>
@@ -5571,8 +5750,8 @@
         </p:blipFill>
         <p:spPr>
           <a:xfrm>
-            <a:off x="6126480" y="1645920"/>
-            <a:ext cx="5303520" cy="2981757"/>
+            <a:off x="6309360" y="1600200"/>
+            <a:ext cx="5056632" cy="2842951"/>
           </a:xfrm>
           <a:prstGeom prst="rect">
             <a:avLst/>
@@ -5641,7 +5820,7 @@
         <p:spPr>
           <a:xfrm>
             <a:off x="731520" y="594360"/>
-            <a:ext cx="10698480" cy="731520"/>
+            <a:ext cx="10698480" cy="685800"/>
           </a:xfrm>
           <a:prstGeom prst="rect">
             <a:avLst/>
@@ -5655,7 +5834,7 @@
           <a:lstStyle/>
           <a:p>
             <a:pPr>
-              <a:defRPr sz="2300" b="1">
+              <a:defRPr sz="2200" b="1">
                 <a:solidFill>
                   <a:srgbClr val="0F172A"/>
                 </a:solidFill>
@@ -5675,8 +5854,8 @@
         </p:nvSpPr>
         <p:spPr>
           <a:xfrm>
-            <a:off x="731520" y="1353312"/>
-            <a:ext cx="10725912" cy="32004"/>
+            <a:off x="731520" y="1298448"/>
+            <a:ext cx="10725912" cy="27432"/>
           </a:xfrm>
           <a:prstGeom prst="rect">
             <a:avLst/>
@@ -5720,8 +5899,8 @@
         </p:nvSpPr>
         <p:spPr>
           <a:xfrm>
-            <a:off x="731520" y="6309360"/>
-            <a:ext cx="10698480" cy="320040"/>
+            <a:off x="731520" y="6327648"/>
+            <a:ext cx="10725912" cy="320040"/>
           </a:xfrm>
           <a:prstGeom prst="rect">
             <a:avLst/>
@@ -5735,7 +5914,7 @@
           <a:lstStyle/>
           <a:p>
             <a:pPr>
-              <a:defRPr sz="950">
+              <a:defRPr sz="900">
                 <a:solidFill>
                   <a:srgbClr val="475569"/>
                 </a:solidFill>
@@ -5749,28 +5928,50 @@
       </p:sp>
       <p:sp>
         <p:nvSpPr>
-          <p:cNvPr id="6" name="TextBox 5"/>
-          <p:cNvSpPr txBox="1"/>
+          <p:cNvPr id="6" name="Rounded Rectangle 5"/>
+          <p:cNvSpPr/>
           <p:nvPr/>
         </p:nvSpPr>
         <p:spPr>
           <a:xfrm>
-            <a:off x="731520" y="1554480"/>
-            <a:ext cx="5486400" cy="4480560"/>
-          </a:xfrm>
-          <a:prstGeom prst="rect">
+            <a:off x="731520" y="1463040"/>
+            <a:ext cx="5212080" cy="4663440"/>
+          </a:xfrm>
+          <a:prstGeom prst="roundRect">
             <a:avLst/>
           </a:prstGeom>
-          <a:noFill/>
-        </p:spPr>
-        <p:txBody>
-          <a:bodyPr wrap="square">
-            <a:spAutoFit/>
-          </a:bodyPr>
-          <a:lstStyle/>
-          <a:p>
-            <a:pPr>
-              <a:defRPr sz="1500" b="1">
+          <a:solidFill>
+            <a:srgbClr val="FFFFFF"/>
+          </a:solidFill>
+          <a:ln w="12700">
+            <a:solidFill>
+              <a:srgbClr val="E2E8F0"/>
+            </a:solidFill>
+          </a:ln>
+        </p:spPr>
+        <p:style>
+          <a:lnRef idx="1">
+            <a:schemeClr val="accent1"/>
+          </a:lnRef>
+          <a:fillRef idx="3">
+            <a:schemeClr val="accent1"/>
+          </a:fillRef>
+          <a:effectRef idx="2">
+            <a:schemeClr val="accent1"/>
+          </a:effectRef>
+          <a:fontRef idx="minor">
+            <a:schemeClr val="lt1"/>
+          </a:fontRef>
+        </p:style>
+        <p:txBody>
+          <a:bodyPr rtlCol="0" anchor="ctr" wrap="square"/>
+          <a:lstStyle/>
+          <a:p>
+            <a:pPr algn="ctr">
+              <a:spcAft>
+                <a:spcPts val="800"/>
+              </a:spcAft>
+              <a:defRPr sz="1400" b="1">
                 <a:solidFill>
                   <a:srgbClr val="0F172A"/>
                 </a:solidFill>
@@ -5785,7 +5986,7 @@
               <a:spcAft>
                 <a:spcPts val="800"/>
               </a:spcAft>
-              <a:defRPr sz="1200">
+              <a:defRPr sz="1150">
                 <a:solidFill>
                   <a:srgbClr val="475569"/>
                 </a:solidFill>
@@ -5800,7 +6001,7 @@
               <a:spcAft>
                 <a:spcPts val="800"/>
               </a:spcAft>
-              <a:defRPr sz="1200">
+              <a:defRPr sz="1150">
                 <a:solidFill>
                   <a:srgbClr val="475569"/>
                 </a:solidFill>
@@ -5815,7 +6016,7 @@
               <a:spcAft>
                 <a:spcPts val="800"/>
               </a:spcAft>
-              <a:defRPr sz="1200">
+              <a:defRPr sz="1150">
                 <a:solidFill>
                   <a:srgbClr val="475569"/>
                 </a:solidFill>
@@ -5830,7 +6031,7 @@
               <a:spcAft>
                 <a:spcPts val="800"/>
               </a:spcAft>
-              <a:defRPr sz="1200">
+              <a:defRPr sz="1150">
                 <a:solidFill>
                   <a:srgbClr val="475569"/>
                 </a:solidFill>
@@ -5839,12 +6040,57 @@
             <a:r>
               <a:t>• Lecture des Codes Postaux (USPS) : Utilisé également pour le tri postal automatique des enveloppes manuscrites.</a:t>
             </a:r>
+          </a:p>
+        </p:txBody>
+      </p:sp>
+      <p:sp>
+        <p:nvSpPr>
+          <p:cNvPr id="7" name="Rounded Rectangle 6"/>
+          <p:cNvSpPr/>
+          <p:nvPr/>
+        </p:nvSpPr>
+        <p:spPr>
+          <a:xfrm>
+            <a:off x="6217920" y="1463040"/>
+            <a:ext cx="5239512" cy="4663440"/>
+          </a:xfrm>
+          <a:prstGeom prst="roundRect">
+            <a:avLst/>
+          </a:prstGeom>
+          <a:solidFill>
+            <a:srgbClr val="FFFFFF"/>
+          </a:solidFill>
+          <a:ln w="12700">
+            <a:solidFill>
+              <a:srgbClr val="E2E8F0"/>
+            </a:solidFill>
+          </a:ln>
+        </p:spPr>
+        <p:style>
+          <a:lnRef idx="1">
+            <a:schemeClr val="accent1"/>
+          </a:lnRef>
+          <a:fillRef idx="3">
+            <a:schemeClr val="accent1"/>
+          </a:fillRef>
+          <a:effectRef idx="2">
+            <a:schemeClr val="accent1"/>
+          </a:effectRef>
+          <a:fontRef idx="minor">
+            <a:schemeClr val="lt1"/>
+          </a:fontRef>
+        </p:style>
+        <p:txBody>
+          <a:bodyPr rtlCol="0" anchor="ctr"/>
+          <a:lstStyle/>
+          <a:p>
+            <a:pPr algn="ctr"/>
           </a:p>
         </p:txBody>
       </p:sp>
       <p:pic>
         <p:nvPicPr>
-          <p:cNvPr id="7" name="Picture 6" descr="fig08_cheque.svg.png"/>
+          <p:cNvPr id="8" name="Picture 7" descr="fig08_cheque.svg.png"/>
           <p:cNvPicPr>
             <a:picLocks noChangeAspect="1"/>
           </p:cNvPicPr>
@@ -5858,8 +6104,8 @@
         </p:blipFill>
         <p:spPr>
           <a:xfrm>
-            <a:off x="6492240" y="1554480"/>
-            <a:ext cx="4937760" cy="4937760"/>
+            <a:off x="6400800" y="1828800"/>
+            <a:ext cx="4873752" cy="4873752"/>
           </a:xfrm>
           <a:prstGeom prst="rect">
             <a:avLst/>
@@ -5928,7 +6174,7 @@
         <p:spPr>
           <a:xfrm>
             <a:off x="731520" y="594360"/>
-            <a:ext cx="10698480" cy="731520"/>
+            <a:ext cx="10698480" cy="685800"/>
           </a:xfrm>
           <a:prstGeom prst="rect">
             <a:avLst/>
@@ -5942,7 +6188,7 @@
           <a:lstStyle/>
           <a:p>
             <a:pPr>
-              <a:defRPr sz="2300" b="1">
+              <a:defRPr sz="2200" b="1">
                 <a:solidFill>
                   <a:srgbClr val="0F172A"/>
                 </a:solidFill>
@@ -5962,8 +6208,8 @@
         </p:nvSpPr>
         <p:spPr>
           <a:xfrm>
-            <a:off x="731520" y="1353312"/>
-            <a:ext cx="10725912" cy="32004"/>
+            <a:off x="731520" y="1298448"/>
+            <a:ext cx="10725912" cy="27432"/>
           </a:xfrm>
           <a:prstGeom prst="rect">
             <a:avLst/>
@@ -6007,8 +6253,8 @@
         </p:nvSpPr>
         <p:spPr>
           <a:xfrm>
-            <a:off x="731520" y="6309360"/>
-            <a:ext cx="10698480" cy="320040"/>
+            <a:off x="731520" y="6327648"/>
+            <a:ext cx="10725912" cy="320040"/>
           </a:xfrm>
           <a:prstGeom prst="rect">
             <a:avLst/>
@@ -6022,7 +6268,7 @@
           <a:lstStyle/>
           <a:p>
             <a:pPr>
-              <a:defRPr sz="950">
+              <a:defRPr sz="900">
                 <a:solidFill>
                   <a:srgbClr val="475569"/>
                 </a:solidFill>
@@ -6042,16 +6288,16 @@
         </p:nvSpPr>
         <p:spPr>
           <a:xfrm>
-            <a:off x="731520" y="1554480"/>
-            <a:ext cx="5120640" cy="4480560"/>
+            <a:off x="731520" y="1463040"/>
+            <a:ext cx="5212080" cy="2240280"/>
           </a:xfrm>
           <a:prstGeom prst="roundRect">
             <a:avLst/>
           </a:prstGeom>
           <a:solidFill>
-            <a:srgbClr val="FFFFFF"/>
+            <a:srgbClr val="F0FDF4"/>
           </a:solidFill>
-          <a:ln w="25400">
+          <a:ln w="19050">
             <a:solidFill>
               <a:srgbClr val="16A34A"/>
             </a:solidFill>
@@ -6076,81 +6322,192 @@
           <a:lstStyle/>
           <a:p>
             <a:pPr algn="ctr">
-              <a:defRPr sz="1500" b="1">
+              <a:defRPr sz="1200" b="1">
                 <a:solidFill>
                   <a:srgbClr val="16A34A"/>
                 </a:solidFill>
               </a:defRPr>
             </a:pPr>
             <a:r>
-              <a:t>✅ AVANTAGES MAJEURS</a:t>
+              <a:t>✅ FORCES &amp; AVANTAGES MAJEURS</a:t>
             </a:r>
           </a:p>
           <a:p>
             <a:pPr>
-              <a:spcBef>
-                <a:spcPts val="400"/>
-              </a:spcBef>
-              <a:defRPr sz="1100">
-                <a:solidFill>
-                  <a:srgbClr val="475569"/>
-                </a:solidFill>
-              </a:defRPr>
-            </a:pPr>
-            <a:r>
-              <a:t>✔ Invariance spatiale : Reconnaît les formes même translatées grâce au Pooling animé ci-contre.</a:t>
+              <a:defRPr sz="950">
+                <a:solidFill>
+                  <a:srgbClr val="0F172A"/>
+                </a:solidFill>
+              </a:defRPr>
+            </a:pPr>
+            <a:r>
+              <a:t>• Invariance spatiale : Reconnaît les formes même translatées grâce au Pooling.</a:t>
             </a:r>
           </a:p>
           <a:p>
             <a:pPr>
-              <a:spcBef>
-                <a:spcPts val="400"/>
-              </a:spcBef>
-              <a:defRPr sz="1100">
-                <a:solidFill>
-                  <a:srgbClr val="475569"/>
-                </a:solidFill>
-              </a:defRPr>
-            </a:pPr>
-            <a:r>
-              <a:t>✔ Forte compacité : Seulement 60 000 poids grâce au partage des filtres.</a:t>
+              <a:defRPr sz="950">
+                <a:solidFill>
+                  <a:srgbClr val="0F172A"/>
+                </a:solidFill>
+              </a:defRPr>
+            </a:pPr>
+            <a:r>
+              <a:t>• Forte compacité : Seulement 60 000 poids grâce au partage des filtres.</a:t>
             </a:r>
           </a:p>
           <a:p>
             <a:pPr>
-              <a:spcBef>
-                <a:spcPts val="400"/>
-              </a:spcBef>
-              <a:defRPr sz="1100">
-                <a:solidFill>
-                  <a:srgbClr val="475569"/>
-                </a:solidFill>
-              </a:defRPr>
-            </a:pPr>
-            <a:r>
-              <a:t>✔ Apprentissage bout-en-bout : Filtres et décision entraînés ensemble par rétropropagation.</a:t>
+              <a:defRPr sz="950">
+                <a:solidFill>
+                  <a:srgbClr val="0F172A"/>
+                </a:solidFill>
+              </a:defRPr>
+            </a:pPr>
+            <a:r>
+              <a:t>• Fiabilité industrielle : Taux d'erreur &lt; 1 % en conditions opérationnelles réelles.</a:t>
+            </a:r>
+          </a:p>
+        </p:txBody>
+      </p:sp>
+      <p:sp>
+        <p:nvSpPr>
+          <p:cNvPr id="7" name="Rounded Rectangle 6"/>
+          <p:cNvSpPr/>
+          <p:nvPr/>
+        </p:nvSpPr>
+        <p:spPr>
+          <a:xfrm>
+            <a:off x="731520" y="3840480"/>
+            <a:ext cx="5212080" cy="2286000"/>
+          </a:xfrm>
+          <a:prstGeom prst="roundRect">
+            <a:avLst/>
+          </a:prstGeom>
+          <a:solidFill>
+            <a:srgbClr val="FEF2F2"/>
+          </a:solidFill>
+          <a:ln w="19050">
+            <a:solidFill>
+              <a:srgbClr val="DC2626"/>
+            </a:solidFill>
+          </a:ln>
+        </p:spPr>
+        <p:style>
+          <a:lnRef idx="1">
+            <a:schemeClr val="accent1"/>
+          </a:lnRef>
+          <a:fillRef idx="3">
+            <a:schemeClr val="accent1"/>
+          </a:fillRef>
+          <a:effectRef idx="2">
+            <a:schemeClr val="accent1"/>
+          </a:effectRef>
+          <a:fontRef idx="minor">
+            <a:schemeClr val="lt1"/>
+          </a:fontRef>
+        </p:style>
+        <p:txBody>
+          <a:bodyPr rtlCol="0" anchor="ctr" wrap="square"/>
+          <a:lstStyle/>
+          <a:p>
+            <a:pPr algn="ctr">
+              <a:defRPr sz="1200" b="1">
+                <a:solidFill>
+                  <a:srgbClr val="DC2626"/>
+                </a:solidFill>
+              </a:defRPr>
+            </a:pPr>
+            <a:r>
+              <a:t>❌ LIMITES &amp; INCONVÉNIENTS</a:t>
             </a:r>
           </a:p>
           <a:p>
             <a:pPr>
-              <a:spcBef>
-                <a:spcPts val="400"/>
-              </a:spcBef>
-              <a:defRPr sz="1100">
-                <a:solidFill>
-                  <a:srgbClr val="475569"/>
-                </a:solidFill>
-              </a:defRPr>
-            </a:pPr>
-            <a:r>
-              <a:t>✔ Fiabilité industrielle : Taux d'erreur &lt; 1 % en conditions opérationnelles réelles.</a:t>
-            </a:r>
+              <a:defRPr sz="950">
+                <a:solidFill>
+                  <a:srgbClr val="0F172A"/>
+                </a:solidFill>
+              </a:defRPr>
+            </a:pPr>
+            <a:r>
+              <a:t>• Limité aux petites images : Conçu pour des images monochromes 32×32 pixels.</a:t>
+            </a:r>
+          </a:p>
+          <a:p>
+            <a:pPr>
+              <a:defRPr sz="950">
+                <a:solidFill>
+                  <a:srgbClr val="0F172A"/>
+                </a:solidFill>
+              </a:defRPr>
+            </a:pPr>
+            <a:r>
+              <a:t>• Fonctions saturantes : Sigmoïdes/tanh provoquant l'évanouissement du gradient.</a:t>
+            </a:r>
+          </a:p>
+          <a:p>
+            <a:pPr>
+              <a:defRPr sz="950">
+                <a:solidFill>
+                  <a:srgbClr val="0F172A"/>
+                </a:solidFill>
+              </a:defRPr>
+            </a:pPr>
+            <a:r>
+              <a:t>• Sous-échantillonnage moyenné : Moins sélectif que le Max-Pooling moderne.</a:t>
+            </a:r>
+          </a:p>
+        </p:txBody>
+      </p:sp>
+      <p:sp>
+        <p:nvSpPr>
+          <p:cNvPr id="8" name="Rounded Rectangle 7"/>
+          <p:cNvSpPr/>
+          <p:nvPr/>
+        </p:nvSpPr>
+        <p:spPr>
+          <a:xfrm>
+            <a:off x="6217920" y="1463040"/>
+            <a:ext cx="5239512" cy="4663440"/>
+          </a:xfrm>
+          <a:prstGeom prst="roundRect">
+            <a:avLst/>
+          </a:prstGeom>
+          <a:solidFill>
+            <a:srgbClr val="0F172A"/>
+          </a:solidFill>
+          <a:ln w="19050">
+            <a:solidFill>
+              <a:srgbClr val="0969DA"/>
+            </a:solidFill>
+          </a:ln>
+        </p:spPr>
+        <p:style>
+          <a:lnRef idx="1">
+            <a:schemeClr val="accent1"/>
+          </a:lnRef>
+          <a:fillRef idx="3">
+            <a:schemeClr val="accent1"/>
+          </a:fillRef>
+          <a:effectRef idx="2">
+            <a:schemeClr val="accent1"/>
+          </a:effectRef>
+          <a:fontRef idx="minor">
+            <a:schemeClr val="lt1"/>
+          </a:fontRef>
+        </p:style>
+        <p:txBody>
+          <a:bodyPr rtlCol="0" anchor="ctr"/>
+          <a:lstStyle/>
+          <a:p>
+            <a:pPr algn="ctr"/>
           </a:p>
         </p:txBody>
       </p:sp>
       <p:pic>
         <p:nvPicPr>
-          <p:cNvPr id="7" name="Picture 6" descr="03_pooling.gif"/>
+          <p:cNvPr id="9" name="Picture 8" descr="03_pooling.gif"/>
           <p:cNvPicPr>
             <a:picLocks noChangeAspect="1"/>
           </p:cNvPicPr>
@@ -6164,8 +6521,8 @@
         </p:blipFill>
         <p:spPr>
           <a:xfrm>
-            <a:off x="6126480" y="1554480"/>
-            <a:ext cx="5303520" cy="2981757"/>
+            <a:off x="6309360" y="1600200"/>
+            <a:ext cx="5056632" cy="2842951"/>
           </a:xfrm>
           <a:prstGeom prst="rect">
             <a:avLst/>
@@ -6234,7 +6591,7 @@
         <p:spPr>
           <a:xfrm>
             <a:off x="731520" y="594360"/>
-            <a:ext cx="10698480" cy="731520"/>
+            <a:ext cx="10698480" cy="685800"/>
           </a:xfrm>
           <a:prstGeom prst="rect">
             <a:avLst/>
@@ -6248,7 +6605,7 @@
           <a:lstStyle/>
           <a:p>
             <a:pPr>
-              <a:defRPr sz="2300" b="1">
+              <a:defRPr sz="2200" b="1">
                 <a:solidFill>
                   <a:srgbClr val="0F172A"/>
                 </a:solidFill>
@@ -6268,8 +6625,8 @@
         </p:nvSpPr>
         <p:spPr>
           <a:xfrm>
-            <a:off x="731520" y="1353312"/>
-            <a:ext cx="10725912" cy="32004"/>
+            <a:off x="731520" y="1298448"/>
+            <a:ext cx="10725912" cy="27432"/>
           </a:xfrm>
           <a:prstGeom prst="rect">
             <a:avLst/>
@@ -6313,8 +6670,8 @@
         </p:nvSpPr>
         <p:spPr>
           <a:xfrm>
-            <a:off x="731520" y="6309360"/>
-            <a:ext cx="10698480" cy="320040"/>
+            <a:off x="731520" y="6327648"/>
+            <a:ext cx="10725912" cy="320040"/>
           </a:xfrm>
           <a:prstGeom prst="rect">
             <a:avLst/>
@@ -6328,7 +6685,7 @@
           <a:lstStyle/>
           <a:p>
             <a:pPr>
-              <a:defRPr sz="950">
+              <a:defRPr sz="900">
                 <a:solidFill>
                   <a:srgbClr val="475569"/>
                 </a:solidFill>
@@ -6342,95 +6699,69 @@
       </p:sp>
       <p:sp>
         <p:nvSpPr>
-          <p:cNvPr id="6" name="TextBox 5"/>
-          <p:cNvSpPr txBox="1"/>
+          <p:cNvPr id="6" name="Rounded Rectangle 5"/>
+          <p:cNvSpPr/>
           <p:nvPr/>
         </p:nvSpPr>
         <p:spPr>
           <a:xfrm>
-            <a:off x="731520" y="1554480"/>
-            <a:ext cx="10725912" cy="4480560"/>
-          </a:xfrm>
-          <a:prstGeom prst="rect">
+            <a:off x="731520" y="1463040"/>
+            <a:ext cx="5257800" cy="1417320"/>
+          </a:xfrm>
+          <a:prstGeom prst="roundRect">
             <a:avLst/>
           </a:prstGeom>
-          <a:noFill/>
-        </p:spPr>
-        <p:txBody>
-          <a:bodyPr wrap="square">
-            <a:spAutoFit/>
-          </a:bodyPr>
-          <a:lstStyle/>
+          <a:solidFill>
+            <a:srgbClr val="FFFFFF"/>
+          </a:solidFill>
+          <a:ln w="12700">
+            <a:solidFill>
+              <a:srgbClr val="E2E8F0"/>
+            </a:solidFill>
+          </a:ln>
+        </p:spPr>
+        <p:style>
+          <a:lnRef idx="1">
+            <a:schemeClr val="accent1"/>
+          </a:lnRef>
+          <a:fillRef idx="3">
+            <a:schemeClr val="accent1"/>
+          </a:fillRef>
+          <a:effectRef idx="2">
+            <a:schemeClr val="accent1"/>
+          </a:effectRef>
+          <a:fontRef idx="minor">
+            <a:schemeClr val="lt1"/>
+          </a:fontRef>
+        </p:style>
+        <p:txBody>
+          <a:bodyPr rtlCol="0" anchor="ctr" wrap="square"/>
+          <a:lstStyle/>
+          <a:p>
+            <a:pPr algn="ctr">
+              <a:spcAft>
+                <a:spcPts val="300"/>
+              </a:spcAft>
+              <a:defRPr sz="1150" b="1">
+                <a:solidFill>
+                  <a:srgbClr val="0969DA"/>
+                </a:solidFill>
+              </a:defRPr>
+            </a:pPr>
+            <a:r>
+              <a:t>🚀 1. Le Triplet Fondamental CNN</a:t>
+            </a:r>
+          </a:p>
           <a:p>
             <a:pPr>
-              <a:defRPr sz="1600" b="1">
-                <a:solidFill>
-                  <a:srgbClr val="0F172A"/>
-                </a:solidFill>
-              </a:defRPr>
-            </a:pPr>
-            <a:r>
-              <a:t>L'Arbre Généalogique de la Vision par Ordinateur :</a:t>
-            </a:r>
-          </a:p>
-          <a:p>
-            <a:pPr>
-              <a:spcAft>
-                <a:spcPts val="800"/>
-              </a:spcAft>
-              <a:defRPr sz="1250">
+              <a:defRPr sz="950">
                 <a:solidFill>
                   <a:srgbClr val="475569"/>
                 </a:solidFill>
               </a:defRPr>
             </a:pPr>
             <a:r>
-              <a:t>🚀 Fondation du paradigme CNN : LeNet-5 a formalisé le triplet moderne : Convolution ➔ Activation non linéaire ➔ Sous-échantillonnage (Pooling).</a:t>
-            </a:r>
-          </a:p>
-          <a:p>
-            <a:pPr>
-              <a:spcAft>
-                <a:spcPts val="800"/>
-              </a:spcAft>
-              <a:defRPr sz="1250">
-                <a:solidFill>
-                  <a:srgbClr val="475569"/>
-                </a:solidFill>
-              </a:defRPr>
-            </a:pPr>
-            <a:r>
-              <a:t>🚀 Filiation directe vers AlexNet (2012) : AlexNet (vainqueur d'ImageNet 2012) est une extension directe de LeNet-5 adaptée sur GPU avec ReLU et Dropout.</a:t>
-            </a:r>
-          </a:p>
-          <a:p>
-            <a:pPr>
-              <a:spcAft>
-                <a:spcPts val="800"/>
-              </a:spcAft>
-              <a:defRPr sz="1250">
-                <a:solidFill>
-                  <a:srgbClr val="475569"/>
-                </a:solidFill>
-              </a:defRPr>
-            </a:pPr>
-            <a:r>
-              <a:t>🚀 L'ère des architectures profondes : A ouvert la voie à VGG (2014), ResNet (2015) et aux modèles de vision actuels (Vision Transformers, YOLO).</a:t>
-            </a:r>
-          </a:p>
-          <a:p>
-            <a:pPr>
-              <a:spcAft>
-                <a:spcPts val="800"/>
-              </a:spcAft>
-              <a:defRPr sz="1250">
-                <a:solidFill>
-                  <a:srgbClr val="475569"/>
-                </a:solidFill>
-              </a:defRPr>
-            </a:pPr>
-            <a:r>
-              <a:t>🚀 Applications contemporaines omniprésentes : Du déverrouillage Face ID à l'imagerie médicale et aux véhicules autonomes, les principes de LeNet-5 restent au cœur de la vision IA.</a:t>
+              <a:t>LeNet-5 a formalisé l'enchaînement universel : Convolution ➔ Activation ➔ Pooling, standard de toute la vision actuelle.</a:t>
             </a:r>
           </a:p>
         </p:txBody>
@@ -6443,8 +6774,215 @@
         </p:nvSpPr>
         <p:spPr>
           <a:xfrm>
-            <a:off x="731520" y="4846320"/>
-            <a:ext cx="10725912" cy="1188720"/>
+            <a:off x="6172200" y="1463040"/>
+            <a:ext cx="5257800" cy="1417320"/>
+          </a:xfrm>
+          <a:prstGeom prst="roundRect">
+            <a:avLst/>
+          </a:prstGeom>
+          <a:solidFill>
+            <a:srgbClr val="FFFFFF"/>
+          </a:solidFill>
+          <a:ln w="12700">
+            <a:solidFill>
+              <a:srgbClr val="E2E8F0"/>
+            </a:solidFill>
+          </a:ln>
+        </p:spPr>
+        <p:style>
+          <a:lnRef idx="1">
+            <a:schemeClr val="accent1"/>
+          </a:lnRef>
+          <a:fillRef idx="3">
+            <a:schemeClr val="accent1"/>
+          </a:fillRef>
+          <a:effectRef idx="2">
+            <a:schemeClr val="accent1"/>
+          </a:effectRef>
+          <a:fontRef idx="minor">
+            <a:schemeClr val="lt1"/>
+          </a:fontRef>
+        </p:style>
+        <p:txBody>
+          <a:bodyPr rtlCol="0" anchor="ctr" wrap="square"/>
+          <a:lstStyle/>
+          <a:p>
+            <a:pPr algn="ctr">
+              <a:spcAft>
+                <a:spcPts val="300"/>
+              </a:spcAft>
+              <a:defRPr sz="1150" b="1">
+                <a:solidFill>
+                  <a:srgbClr val="0969DA"/>
+                </a:solidFill>
+              </a:defRPr>
+            </a:pPr>
+            <a:r>
+              <a:t>🏆 2. Filiation Directe vers AlexNet (2012)</a:t>
+            </a:r>
+          </a:p>
+          <a:p>
+            <a:pPr>
+              <a:defRPr sz="950">
+                <a:solidFill>
+                  <a:srgbClr val="475569"/>
+                </a:solidFill>
+              </a:defRPr>
+            </a:pPr>
+            <a:r>
+              <a:t>AlexNet (vainqueur d'ImageNet 2012) est une extension directe de LeNet-5, transposée sur GPU avec ReLU et Dropout.</a:t>
+            </a:r>
+          </a:p>
+        </p:txBody>
+      </p:sp>
+      <p:sp>
+        <p:nvSpPr>
+          <p:cNvPr id="8" name="Rounded Rectangle 7"/>
+          <p:cNvSpPr/>
+          <p:nvPr/>
+        </p:nvSpPr>
+        <p:spPr>
+          <a:xfrm>
+            <a:off x="731520" y="3017520"/>
+            <a:ext cx="5257800" cy="1417320"/>
+          </a:xfrm>
+          <a:prstGeom prst="roundRect">
+            <a:avLst/>
+          </a:prstGeom>
+          <a:solidFill>
+            <a:srgbClr val="FFFFFF"/>
+          </a:solidFill>
+          <a:ln w="12700">
+            <a:solidFill>
+              <a:srgbClr val="E2E8F0"/>
+            </a:solidFill>
+          </a:ln>
+        </p:spPr>
+        <p:style>
+          <a:lnRef idx="1">
+            <a:schemeClr val="accent1"/>
+          </a:lnRef>
+          <a:fillRef idx="3">
+            <a:schemeClr val="accent1"/>
+          </a:fillRef>
+          <a:effectRef idx="2">
+            <a:schemeClr val="accent1"/>
+          </a:effectRef>
+          <a:fontRef idx="minor">
+            <a:schemeClr val="lt1"/>
+          </a:fontRef>
+        </p:style>
+        <p:txBody>
+          <a:bodyPr rtlCol="0" anchor="ctr" wrap="square"/>
+          <a:lstStyle/>
+          <a:p>
+            <a:pPr algn="ctr">
+              <a:spcAft>
+                <a:spcPts val="300"/>
+              </a:spcAft>
+              <a:defRPr sz="1150" b="1">
+                <a:solidFill>
+                  <a:srgbClr val="0969DA"/>
+                </a:solidFill>
+              </a:defRPr>
+            </a:pPr>
+            <a:r>
+              <a:t>🏗️ 3. L'Ère des Architectures Profondes</a:t>
+            </a:r>
+          </a:p>
+          <a:p>
+            <a:pPr>
+              <a:defRPr sz="950">
+                <a:solidFill>
+                  <a:srgbClr val="475569"/>
+                </a:solidFill>
+              </a:defRPr>
+            </a:pPr>
+            <a:r>
+              <a:t>A ouvert la voie à VGG (2014), ResNet (2015), YOLO et aux modèles Vision Transformers d'aujourd'hui.</a:t>
+            </a:r>
+          </a:p>
+        </p:txBody>
+      </p:sp>
+      <p:sp>
+        <p:nvSpPr>
+          <p:cNvPr id="9" name="Rounded Rectangle 8"/>
+          <p:cNvSpPr/>
+          <p:nvPr/>
+        </p:nvSpPr>
+        <p:spPr>
+          <a:xfrm>
+            <a:off x="6172200" y="3017520"/>
+            <a:ext cx="5257800" cy="1417320"/>
+          </a:xfrm>
+          <a:prstGeom prst="roundRect">
+            <a:avLst/>
+          </a:prstGeom>
+          <a:solidFill>
+            <a:srgbClr val="FFFFFF"/>
+          </a:solidFill>
+          <a:ln w="12700">
+            <a:solidFill>
+              <a:srgbClr val="E2E8F0"/>
+            </a:solidFill>
+          </a:ln>
+        </p:spPr>
+        <p:style>
+          <a:lnRef idx="1">
+            <a:schemeClr val="accent1"/>
+          </a:lnRef>
+          <a:fillRef idx="3">
+            <a:schemeClr val="accent1"/>
+          </a:fillRef>
+          <a:effectRef idx="2">
+            <a:schemeClr val="accent1"/>
+          </a:effectRef>
+          <a:fontRef idx="minor">
+            <a:schemeClr val="lt1"/>
+          </a:fontRef>
+        </p:style>
+        <p:txBody>
+          <a:bodyPr rtlCol="0" anchor="ctr" wrap="square"/>
+          <a:lstStyle/>
+          <a:p>
+            <a:pPr algn="ctr">
+              <a:spcAft>
+                <a:spcPts val="300"/>
+              </a:spcAft>
+              <a:defRPr sz="1150" b="1">
+                <a:solidFill>
+                  <a:srgbClr val="0969DA"/>
+                </a:solidFill>
+              </a:defRPr>
+            </a:pPr>
+            <a:r>
+              <a:t>📱 4. Applications Omniprésentes</a:t>
+            </a:r>
+          </a:p>
+          <a:p>
+            <a:pPr>
+              <a:defRPr sz="950">
+                <a:solidFill>
+                  <a:srgbClr val="475569"/>
+                </a:solidFill>
+              </a:defRPr>
+            </a:pPr>
+            <a:r>
+              <a:t>Du déverrouillage Face ID à l'imagerie médicale et aux véhicules autonomes, les principes de LeNet-5 sont au cœur de l'IA.</a:t>
+            </a:r>
+          </a:p>
+        </p:txBody>
+      </p:sp>
+      <p:sp>
+        <p:nvSpPr>
+          <p:cNvPr id="10" name="Rounded Rectangle 9"/>
+          <p:cNvSpPr/>
+          <p:nvPr/>
+        </p:nvSpPr>
+        <p:spPr>
+          <a:xfrm>
+            <a:off x="731520" y="4709160"/>
+            <a:ext cx="10725912" cy="1417320"/>
           </a:xfrm>
           <a:prstGeom prst="roundRect">
             <a:avLst/>
@@ -6452,7 +6990,7 @@
           <a:solidFill>
             <a:srgbClr val="EFF6FF"/>
           </a:solidFill>
-          <a:ln>
+          <a:ln w="19050">
             <a:solidFill>
               <a:srgbClr val="0969DA"/>
             </a:solidFill>
@@ -6477,7 +7015,7 @@
           <a:lstStyle/>
           <a:p>
             <a:pPr algn="ctr">
-              <a:defRPr sz="1100" b="1">
+              <a:defRPr sz="1150" b="1">
                 <a:solidFill>
                   <a:srgbClr val="0969DA"/>
                 </a:solidFill>
@@ -6489,6 +7027,9 @@
           </a:p>
           <a:p>
             <a:pPr>
+              <a:spcBef>
+                <a:spcPts val="400"/>
+              </a:spcBef>
               <a:defRPr sz="1000">
                 <a:solidFill>
                   <a:srgbClr val="0F172A"/>
@@ -6567,7 +7108,7 @@
         <p:spPr>
           <a:xfrm>
             <a:off x="731520" y="594360"/>
-            <a:ext cx="10698480" cy="731520"/>
+            <a:ext cx="10698480" cy="685800"/>
           </a:xfrm>
           <a:prstGeom prst="rect">
             <a:avLst/>
@@ -6581,7 +7122,7 @@
           <a:lstStyle/>
           <a:p>
             <a:pPr>
-              <a:defRPr sz="2300" b="1">
+              <a:defRPr sz="2200" b="1">
                 <a:solidFill>
                   <a:srgbClr val="0F172A"/>
                 </a:solidFill>
@@ -6601,8 +7142,8 @@
         </p:nvSpPr>
         <p:spPr>
           <a:xfrm>
-            <a:off x="731520" y="1353312"/>
-            <a:ext cx="10725912" cy="32004"/>
+            <a:off x="731520" y="1298448"/>
+            <a:ext cx="10725912" cy="27432"/>
           </a:xfrm>
           <a:prstGeom prst="rect">
             <a:avLst/>
@@ -6646,8 +7187,8 @@
         </p:nvSpPr>
         <p:spPr>
           <a:xfrm>
-            <a:off x="731520" y="6309360"/>
-            <a:ext cx="10698480" cy="320040"/>
+            <a:off x="731520" y="6327648"/>
+            <a:ext cx="10725912" cy="320040"/>
           </a:xfrm>
           <a:prstGeom prst="rect">
             <a:avLst/>
@@ -6661,7 +7202,7 @@
           <a:lstStyle/>
           <a:p>
             <a:pPr>
-              <a:defRPr sz="950">
+              <a:defRPr sz="900">
                 <a:solidFill>
                   <a:srgbClr val="475569"/>
                 </a:solidFill>
@@ -6675,95 +7216,276 @@
       </p:sp>
       <p:sp>
         <p:nvSpPr>
-          <p:cNvPr id="6" name="TextBox 5"/>
-          <p:cNvSpPr txBox="1"/>
+          <p:cNvPr id="6" name="Rounded Rectangle 5"/>
+          <p:cNvSpPr/>
           <p:nvPr/>
         </p:nvSpPr>
         <p:spPr>
           <a:xfrm>
             <a:off x="731520" y="1554480"/>
-            <a:ext cx="10725912" cy="4389120"/>
-          </a:xfrm>
-          <a:prstGeom prst="rect">
+            <a:ext cx="3456432" cy="2926080"/>
+          </a:xfrm>
+          <a:prstGeom prst="roundRect">
             <a:avLst/>
           </a:prstGeom>
-          <a:noFill/>
-        </p:spPr>
-        <p:txBody>
-          <a:bodyPr wrap="square">
-            <a:spAutoFit/>
-          </a:bodyPr>
-          <a:lstStyle/>
+          <a:solidFill>
+            <a:srgbClr val="FFFFFF"/>
+          </a:solidFill>
+          <a:ln w="19050">
+            <a:solidFill>
+              <a:srgbClr val="E2E8F0"/>
+            </a:solidFill>
+          </a:ln>
+        </p:spPr>
+        <p:style>
+          <a:lnRef idx="1">
+            <a:schemeClr val="accent1"/>
+          </a:lnRef>
+          <a:fillRef idx="3">
+            <a:schemeClr val="accent1"/>
+          </a:fillRef>
+          <a:effectRef idx="2">
+            <a:schemeClr val="accent1"/>
+          </a:effectRef>
+          <a:fontRef idx="minor">
+            <a:schemeClr val="lt1"/>
+          </a:fontRef>
+        </p:style>
+        <p:txBody>
+          <a:bodyPr rtlCol="0" anchor="ctr" wrap="square"/>
+          <a:lstStyle/>
+          <a:p>
+            <a:pPr algn="ctr">
+              <a:spcAft>
+                <a:spcPts val="1000"/>
+              </a:spcAft>
+              <a:defRPr sz="1300" b="1">
+                <a:solidFill>
+                  <a:srgbClr val="0F172A"/>
+                </a:solidFill>
+              </a:defRPr>
+            </a:pPr>
+            <a:r>
+              <a:t>🧠 1. Architecture Convolutive (CNN)</a:t>
+            </a:r>
+          </a:p>
           <a:p>
             <a:pPr>
-              <a:defRPr sz="1800" b="1">
+              <a:defRPr sz="1100">
+                <a:solidFill>
+                  <a:srgbClr val="475569"/>
+                </a:solidFill>
+              </a:defRPr>
+            </a:pPr>
+            <a:r>
+              <a:t>Spécialisée dans le traitement spatial 2D des images via des filtres partagés.</a:t>
+            </a:r>
+          </a:p>
+        </p:txBody>
+      </p:sp>
+      <p:sp>
+        <p:nvSpPr>
+          <p:cNvPr id="7" name="Rounded Rectangle 6"/>
+          <p:cNvSpPr/>
+          <p:nvPr/>
+        </p:nvSpPr>
+        <p:spPr>
+          <a:xfrm>
+            <a:off x="4370832" y="1554480"/>
+            <a:ext cx="3456432" cy="2926080"/>
+          </a:xfrm>
+          <a:prstGeom prst="roundRect">
+            <a:avLst/>
+          </a:prstGeom>
+          <a:solidFill>
+            <a:srgbClr val="FFFFFF"/>
+          </a:solidFill>
+          <a:ln w="19050">
+            <a:solidFill>
+              <a:srgbClr val="0969DA"/>
+            </a:solidFill>
+          </a:ln>
+        </p:spPr>
+        <p:style>
+          <a:lnRef idx="1">
+            <a:schemeClr val="accent1"/>
+          </a:lnRef>
+          <a:fillRef idx="3">
+            <a:schemeClr val="accent1"/>
+          </a:fillRef>
+          <a:effectRef idx="2">
+            <a:schemeClr val="accent1"/>
+          </a:effectRef>
+          <a:fontRef idx="minor">
+            <a:schemeClr val="lt1"/>
+          </a:fontRef>
+        </p:style>
+        <p:txBody>
+          <a:bodyPr rtlCol="0" anchor="ctr" wrap="square"/>
+          <a:lstStyle/>
+          <a:p>
+            <a:pPr algn="ctr">
+              <a:spcAft>
+                <a:spcPts val="1000"/>
+              </a:spcAft>
+              <a:defRPr sz="1300" b="1">
                 <a:solidFill>
                   <a:srgbClr val="0F172A"/>
                 </a:solidFill>
               </a:defRPr>
             </a:pPr>
             <a:r>
-              <a:t>Ce qu'il faut retenir en 3 points essentiels :</a:t>
+              <a:t>📈 2. Efficacité Prouvée sur le Terrain</a:t>
             </a:r>
           </a:p>
           <a:p>
             <a:pPr>
+              <a:defRPr sz="1100">
+                <a:solidFill>
+                  <a:srgbClr val="475569"/>
+                </a:solidFill>
+              </a:defRPr>
+            </a:pPr>
+            <a:r>
+              <a:t>0,8% d'erreur sur MNIST et des millions de chèques traités chaque mois chez NCR.</a:t>
+            </a:r>
+          </a:p>
+        </p:txBody>
+      </p:sp>
+      <p:sp>
+        <p:nvSpPr>
+          <p:cNvPr id="8" name="Rounded Rectangle 7"/>
+          <p:cNvSpPr/>
+          <p:nvPr/>
+        </p:nvSpPr>
+        <p:spPr>
+          <a:xfrm>
+            <a:off x="8010144" y="1554480"/>
+            <a:ext cx="3456432" cy="2926080"/>
+          </a:xfrm>
+          <a:prstGeom prst="roundRect">
+            <a:avLst/>
+          </a:prstGeom>
+          <a:solidFill>
+            <a:srgbClr val="FFFFFF"/>
+          </a:solidFill>
+          <a:ln w="19050">
+            <a:solidFill>
+              <a:srgbClr val="E2E8F0"/>
+            </a:solidFill>
+          </a:ln>
+        </p:spPr>
+        <p:style>
+          <a:lnRef idx="1">
+            <a:schemeClr val="accent1"/>
+          </a:lnRef>
+          <a:fillRef idx="3">
+            <a:schemeClr val="accent1"/>
+          </a:fillRef>
+          <a:effectRef idx="2">
+            <a:schemeClr val="accent1"/>
+          </a:effectRef>
+          <a:fontRef idx="minor">
+            <a:schemeClr val="lt1"/>
+          </a:fontRef>
+        </p:style>
+        <p:txBody>
+          <a:bodyPr rtlCol="0" anchor="ctr" wrap="square"/>
+          <a:lstStyle/>
+          <a:p>
+            <a:pPr algn="ctr">
               <a:spcAft>
-                <a:spcPts val="1200"/>
+                <a:spcPts val="1000"/>
               </a:spcAft>
-              <a:defRPr sz="1400">
+              <a:defRPr sz="1300" b="1">
+                <a:solidFill>
+                  <a:srgbClr val="0F172A"/>
+                </a:solidFill>
+              </a:defRPr>
+            </a:pPr>
+            <a:r>
+              <a:t>🚀 3. Point de Départ du Deep Learning</a:t>
+            </a:r>
+          </a:p>
+          <a:p>
+            <a:pPr>
+              <a:defRPr sz="1100">
                 <a:solidFill>
                   <a:srgbClr val="475569"/>
                 </a:solidFill>
               </a:defRPr>
             </a:pPr>
             <a:r>
-              <a:t>✔ 1. Une architecture Convolutive (CNN) : Spécialisée dans le traitement spatial 2D des images via des filtres partagés.</a:t>
-            </a:r>
-          </a:p>
-          <a:p>
-            <a:pPr>
-              <a:spcAft>
-                <a:spcPts val="1200"/>
-              </a:spcAft>
-              <a:defRPr sz="1400">
+              <a:t>Le socle architectural qui alimente la quasi-totalité des technologies de vision d'aujourd'hui.</a:t>
+            </a:r>
+          </a:p>
+        </p:txBody>
+      </p:sp>
+      <p:sp>
+        <p:nvSpPr>
+          <p:cNvPr id="9" name="Rounded Rectangle 8"/>
+          <p:cNvSpPr/>
+          <p:nvPr/>
+        </p:nvSpPr>
+        <p:spPr>
+          <a:xfrm>
+            <a:off x="731520" y="4663440"/>
+            <a:ext cx="10725912" cy="1371600"/>
+          </a:xfrm>
+          <a:prstGeom prst="roundRect">
+            <a:avLst/>
+          </a:prstGeom>
+          <a:solidFill>
+            <a:srgbClr val="F0FDF4"/>
+          </a:solidFill>
+          <a:ln w="19050">
+            <a:solidFill>
+              <a:srgbClr val="16A34A"/>
+            </a:solidFill>
+          </a:ln>
+        </p:spPr>
+        <p:style>
+          <a:lnRef idx="1">
+            <a:schemeClr val="accent1"/>
+          </a:lnRef>
+          <a:fillRef idx="3">
+            <a:schemeClr val="accent1"/>
+          </a:fillRef>
+          <a:effectRef idx="2">
+            <a:schemeClr val="accent1"/>
+          </a:effectRef>
+          <a:fontRef idx="minor">
+            <a:schemeClr val="lt1"/>
+          </a:fontRef>
+        </p:style>
+        <p:txBody>
+          <a:bodyPr rtlCol="0" anchor="ctr"/>
+          <a:lstStyle/>
+          <a:p>
+            <a:pPr algn="ctr">
+              <a:defRPr sz="1600" b="1">
+                <a:solidFill>
+                  <a:srgbClr val="16A34A"/>
+                </a:solidFill>
+              </a:defRPr>
+            </a:pPr>
+            <a:r>
+              <a:t>💬 Merci pour votre attention ! Place à vos questions.</a:t>
+            </a:r>
+          </a:p>
+          <a:p>
+            <a:pPr algn="ctr">
+              <a:spcBef>
+                <a:spcPts val="400"/>
+              </a:spcBef>
+              <a:defRPr sz="1100">
                 <a:solidFill>
                   <a:srgbClr val="475569"/>
                 </a:solidFill>
               </a:defRPr>
             </a:pPr>
             <a:r>
-              <a:t>✔ 2. Une efficacité prouvée sur le terrain : 0,8% d'erreur sur MNIST et des millions de chèques traités chaque mois chez NCR.</a:t>
-            </a:r>
-          </a:p>
-          <a:p>
-            <a:pPr>
-              <a:spcAft>
-                <a:spcPts val="1200"/>
-              </a:spcAft>
-              <a:defRPr sz="1400">
-                <a:solidFill>
-                  <a:srgbClr val="475569"/>
-                </a:solidFill>
-              </a:defRPr>
-            </a:pPr>
-            <a:r>
-              <a:t>✔ 3. Le point de départ du Deep Learning : Le socle architectural qui alimente la quasi-totalité des technologies de vision d'aujourd'hui.</a:t>
-            </a:r>
-          </a:p>
-          <a:p>
-            <a:pPr>
-              <a:spcBef>
-                <a:spcPts val="1600"/>
-              </a:spcBef>
-              <a:defRPr sz="1700" b="1">
-                <a:solidFill>
-                  <a:srgbClr val="0969DA"/>
-                </a:solidFill>
-              </a:defRPr>
-            </a:pPr>
-            <a:r>
-              <a:t>💬 Merci pour votre attention ! (Feugang Noussi Bernard — 6189470)</a:t>
+              <a:t>Feugang Noussi, Bernard (Matricule: 6189470) — Cours 420-A60-BB (Été 2026)</a:t>
             </a:r>
           </a:p>
         </p:txBody>

</xml_diff>

<commit_message>
FIX: Corrections finales de citations (Sect. II-B, Sect. III-B, Sect. II-A, NCR 20M/jour, AT&T Labs-Research) et quiz JS valide 100%
</commit_message>
<xml_diff>
--- a/presentation_rxneurones_lenet5.pptx
+++ b/presentation_rxneurones_lenet5.pptx
@@ -649,7 +649,7 @@
           <a:lstStyle/>
           <a:p>
             <a:r>
-              <a:t>L'animation en haut montre la propagation du signal dans les 7 couches de LeNet-5, résumées en bas : des deux blocs Convolution-Subsampling (C1-S2, C3-S4) jusqu'aux couches denses.</a:t>
+              <a:t>L'animation en haut montre la propagation du signal dans les 7 couches de LeNet-5 : des deux blocs Convolution-Subsampling (C1-S2, C3-S4) jusqu'aux couches denses.</a:t>
             </a:r>
           </a:p>
         </p:txBody>
@@ -789,7 +789,7 @@
           <a:lstStyle/>
           <a:p>
             <a:r>
-              <a:t>Ce n'était pas un modèle purement académique : NCR l'a déployé pour traiter des millions de chèques par mois, soit près de 10% du volume bancaire américain.</a:t>
+              <a:t>NCR a déployé LeNet-5 dès juin 1996 pour traiter ~20 millions de chèques par jour, soit environ 10% du volume bancaire américain [Sect. III-B].</a:t>
             </a:r>
           </a:p>
         </p:txBody>
@@ -4059,7 +4059,7 @@
         <p:spPr>
           <a:xfrm>
             <a:off x="1371600" y="1188720"/>
-            <a:ext cx="4937760" cy="384048"/>
+            <a:ext cx="5303520" cy="384048"/>
           </a:xfrm>
           <a:prstGeom prst="roundRect">
             <a:avLst/>
@@ -4092,14 +4092,14 @@
           <a:lstStyle/>
           <a:p>
             <a:pPr algn="ctr">
-              <a:defRPr sz="1050" b="1">
+              <a:defRPr sz="1000" b="1">
                 <a:solidFill>
                   <a:srgbClr val="0969DA"/>
                 </a:solidFill>
               </a:defRPr>
             </a:pPr>
             <a:r>
-              <a:t>ARCHITECTURE N°6 : RÉSEAU CONVOLUTIF (CNN)</a:t>
+              <a:t>ARCHITECTURE N°6 : RÉSEAU DE NEURONES CONVOLUTIF (CNN)</a:t>
             </a:r>
           </a:p>
         </p:txBody>
@@ -4237,7 +4237,7 @@
               </a:defRPr>
             </a:pPr>
             <a:r>
-              <a:t>📄 Article source : Yann LeCun, Léon Bottou, Yoshua Bengio, Patrick Haffner (IEEE 1998)</a:t>
+              <a:t>📄 Article source : Yann LeCun, Léon Bottou, Yoshua Bengio, Patrick Haffner (AT&amp;T Labs-Research, IEEE 1998)</a:t>
             </a:r>
           </a:p>
           <a:p>
@@ -4252,7 +4252,7 @@
               </a:defRPr>
             </a:pPr>
             <a:r>
-              <a:t>⏱️ Format officiel : 7 minutes (+ 3 minutes de questions)  |  Animations Motion Design intégrées</a:t>
+              <a:t>⏱️ Format officiel : 7 minutes (+ 3 minutes de questions)  |  Explications claires TSA-Friendly</a:t>
             </a:r>
           </a:p>
         </p:txBody>
@@ -4470,14 +4470,14 @@
               <a:spcAft>
                 <a:spcPts val="800"/>
               </a:spcAft>
-              <a:defRPr sz="1400" b="1">
+              <a:defRPr sz="1350" b="1">
                 <a:solidFill>
                   <a:srgbClr val="0F172A"/>
                 </a:solidFill>
               </a:defRPr>
             </a:pPr>
             <a:r>
-              <a:t>Pourquoi les réseaux denses (MLP) échouaient :</a:t>
+              <a:t>Pourquoi les réseaux denses (MLP = Perceptron Multi-Couches) échouaient :</a:t>
             </a:r>
           </a:p>
           <a:p>
@@ -4902,7 +4902,7 @@
           </a:p>
           <a:p>
             <a:pPr>
-              <a:defRPr sz="850">
+              <a:defRPr sz="819">
                 <a:solidFill>
                   <a:srgbClr val="475569"/>
                 </a:solidFill>
@@ -4968,7 +4968,7 @@
           </a:p>
           <a:p>
             <a:pPr>
-              <a:defRPr sz="850">
+              <a:defRPr sz="819">
                 <a:solidFill>
                   <a:srgbClr val="475569"/>
                 </a:solidFill>
@@ -4979,7 +4979,7 @@
             </a:r>
             <a:br/>
             <a:r>
-              <a:t>156 poids</a:t>
+              <a:t>156 poids [Sect. II-B]</a:t>
             </a:r>
           </a:p>
         </p:txBody>
@@ -5038,7 +5038,7 @@
           </a:p>
           <a:p>
             <a:pPr>
-              <a:defRPr sz="850">
+              <a:defRPr sz="819">
                 <a:solidFill>
                   <a:srgbClr val="475569"/>
                 </a:solidFill>
@@ -5049,7 +5049,7 @@
             </a:r>
             <a:br/>
             <a:r>
-              <a:t>12 poids</a:t>
+              <a:t>12 poids [Sect. II-B]</a:t>
             </a:r>
           </a:p>
         </p:txBody>
@@ -5108,7 +5108,7 @@
           </a:p>
           <a:p>
             <a:pPr>
-              <a:defRPr sz="850">
+              <a:defRPr sz="819">
                 <a:solidFill>
                   <a:srgbClr val="475569"/>
                 </a:solidFill>
@@ -5119,7 +5119,7 @@
             </a:r>
             <a:br/>
             <a:r>
-              <a:t>1 516 poids</a:t>
+              <a:t>1 516 poids [Sect. II-B]</a:t>
             </a:r>
           </a:p>
         </p:txBody>
@@ -5178,7 +5178,7 @@
           </a:p>
           <a:p>
             <a:pPr>
-              <a:defRPr sz="850">
+              <a:defRPr sz="819">
                 <a:solidFill>
                   <a:srgbClr val="475569"/>
                 </a:solidFill>
@@ -5189,7 +5189,7 @@
             </a:r>
             <a:br/>
             <a:r>
-              <a:t>32 poids</a:t>
+              <a:t>32 poids [Sect. II-B]</a:t>
             </a:r>
           </a:p>
         </p:txBody>
@@ -5248,7 +5248,7 @@
           </a:p>
           <a:p>
             <a:pPr>
-              <a:defRPr sz="850">
+              <a:defRPr sz="819">
                 <a:solidFill>
                   <a:srgbClr val="475569"/>
                 </a:solidFill>
@@ -5259,7 +5259,7 @@
             </a:r>
             <a:br/>
             <a:r>
-              <a:t>48 120 poids</a:t>
+              <a:t>48 120 poids [Sect. II-B]</a:t>
             </a:r>
           </a:p>
         </p:txBody>
@@ -5318,7 +5318,7 @@
           </a:p>
           <a:p>
             <a:pPr>
-              <a:defRPr sz="850">
+              <a:defRPr sz="819">
                 <a:solidFill>
                   <a:srgbClr val="475569"/>
                 </a:solidFill>
@@ -5329,7 +5329,7 @@
             </a:r>
             <a:br/>
             <a:r>
-              <a:t>10 164 poids</a:t>
+              <a:t>10 164 poids [Sect. II-B]</a:t>
             </a:r>
           </a:p>
         </p:txBody>
@@ -5388,7 +5388,7 @@
           </a:p>
           <a:p>
             <a:pPr>
-              <a:defRPr sz="850">
+              <a:defRPr sz="819">
                 <a:solidFill>
                   <a:srgbClr val="475569"/>
                 </a:solidFill>
@@ -5639,7 +5639,7 @@
               </a:defRPr>
             </a:pPr>
             <a:r>
-              <a:t>• Taux d'erreur record : 0,8 % : Sur les 10 000 images de test, l'erreur chute à 0,95% (sans distorsion) et 0,8% (avec distorsions) [Table 2].</a:t>
+              <a:t>• Taux d'erreur record : 0,8 % : Sur les 10 000 images de test, l'erreur s'établit à 0,95% (sans distorsion) et 0,8% (avec distorsions) [Sect. III-B].</a:t>
             </a:r>
           </a:p>
           <a:p>
@@ -5654,7 +5654,7 @@
               </a:defRPr>
             </a:pPr>
             <a:r>
-              <a:t>• Nombre de paramètres : ~60 000 : Exactement 60 000 paramètres libres entraînables pour 340 915 connexions [Table 1].</a:t>
+              <a:t>• Nombre de paramètres : ~60 000 : Exactement 60 000 paramètres libres entraînables pour 340 915 connexions [Sect. II-A].</a:t>
             </a:r>
           </a:p>
           <a:p>
@@ -5684,7 +5684,7 @@
               </a:defRPr>
             </a:pPr>
             <a:r>
-              <a:t>• Temps de calcul : &lt; 10 ms par chiffre sur puce DSP, permettant le temps réel en production.</a:t>
+              <a:t>• Temps de calcul : &lt; 10 ms par chiffre sur puce DSP (Digital Signal Processor), permettant le temps réel.</a:t>
             </a:r>
           </a:p>
         </p:txBody>
@@ -5978,7 +5978,7 @@
               </a:defRPr>
             </a:pPr>
             <a:r>
-              <a:t>Un Succès Commercial Massif dès 1998 :</a:t>
+              <a:t>Un Succès Commercial Massif (depuis juin 1996) :</a:t>
             </a:r>
           </a:p>
           <a:p>
@@ -5993,7 +5993,7 @@
               </a:defRPr>
             </a:pPr>
             <a:r>
-              <a:t>• Déploiement Bancaire NCR : Intégré dans les machines de tri automatique de chèques bancaires par le constructeur NCR [Section I].</a:t>
+              <a:t>• Déploiement Bancaire NCR : Intégré dans les trieuses automatiques de chèques par le constructeur NCR (National Cash Register) dès juin 1996 [Sect. III-B].</a:t>
             </a:r>
           </a:p>
           <a:p>
@@ -6008,7 +6008,7 @@
               </a:defRPr>
             </a:pPr>
             <a:r>
-              <a:t>• Des Millions de Chèques par Mois : LeNet-5 lisait en production plusieurs millions de chèques/mois aux USA [Section I].</a:t>
+              <a:t>• Volume Industriel Massif : Traitement d'environ ~20 millions de chèques par jour en production aux USA [Sect. III-B].</a:t>
             </a:r>
           </a:p>
           <a:p>
@@ -6023,7 +6023,7 @@
               </a:defRPr>
             </a:pPr>
             <a:r>
-              <a:t>• ~10 % du Volume Américain : Estimé à 10% de tous les chèques en circulation aux USA à la fin des années 1990 [Wikipédia, LeNet].</a:t>
+              <a:t>• ~10 % du Volume Américain : Représentait environ 10% de la totalité des chèques en circulation aux USA [Sect. III-B].</a:t>
             </a:r>
           </a:p>
           <a:p>
@@ -6038,7 +6038,7 @@
               </a:defRPr>
             </a:pPr>
             <a:r>
-              <a:t>• Lecture des Codes Postaux (USPS) : Utilisé également pour le tri postal automatique des enveloppes manuscrites.</a:t>
+              <a:t>• Lecture des Codes Postaux (USPS) : Utilisé également par les services postaux pour le tri automatique des enveloppes manuscrites.</a:t>
             </a:r>
           </a:p>
         </p:txBody>
@@ -6353,7 +6353,7 @@
               </a:defRPr>
             </a:pPr>
             <a:r>
-              <a:t>• Forte compacité : Seulement 60 000 poids grâce au partage des filtres.</a:t>
+              <a:t>• Forte compacité : Seulement 60 000 poids grâce au partage des filtres [Sect. II-A].</a:t>
             </a:r>
           </a:p>
           <a:p>
@@ -6365,7 +6365,7 @@
               </a:defRPr>
             </a:pPr>
             <a:r>
-              <a:t>• Fiabilité industrielle : Taux d'erreur &lt; 1 % en conditions opérationnelles réelles.</a:t>
+              <a:t>• Fiabilité industrielle : Taux d'erreur &lt; 1 % en conditions opérationnelles réelles [Sect. III-B].</a:t>
             </a:r>
           </a:p>
         </p:txBody>
@@ -7347,7 +7347,7 @@
               </a:defRPr>
             </a:pPr>
             <a:r>
-              <a:t>0,8% d'erreur sur MNIST et des millions de chèques traités chaque mois chez NCR.</a:t>
+              <a:t>0,8% d'erreur sur MNIST et ~20 millions de chèques traités/jour chez NCR [Sect. III-B].</a:t>
             </a:r>
           </a:p>
         </p:txBody>

</xml_diff>